<commit_message>
Refresh application operating report with hybrid AI recipes and export packs.
Rebuild Markdown, Word, PowerPoint, and PDF for report 19 with three-officer-tools summary, updated Vitest/pytest/E2E counts, and regenerated architecture diagrams.
</commit_message>
<xml_diff>
--- a/Discussions/19-APPLICATION_OPERATING_REPORT.pptx
+++ b/Discussions/19-APPLICATION_OPERATING_REPORT.pptx
@@ -28,6 +28,7 @@
     <p:sldId id="276" r:id="rId27"/>
     <p:sldId id="277" r:id="rId28"/>
     <p:sldId id="278" r:id="rId29"/>
+    <p:sldId id="279" r:id="rId30"/>
   </p:sldIdLst>
   <p:sldSz cx="12191695" cy="6858000" type="screen4x3"/>
   <p:notesSz cx="6858000" cy="9144000"/>
@@ -3534,6 +3535,844 @@
                 <a:cs typeface="TH Sarabun New"/>
                 <a:latin typeface="TH Sarabun New"/>
               </a:rPr>
+              <a:t>13 หมวด TOR และจุด HITL</a:t>
+            </a:r>
+          </a:p>
+        </p:txBody>
+      </p:sp>
+      <p:graphicFrame>
+        <p:nvGraphicFramePr>
+          <p:cNvPr id="6" name="Table 5"/>
+          <p:cNvGraphicFramePr>
+            <a:graphicFrameLocks noGrp="1"/>
+          </p:cNvGraphicFramePr>
+          <p:nvPr/>
+        </p:nvGraphicFramePr>
+        <p:xfrm>
+          <a:off x="457200" y="960120"/>
+          <a:ext cx="11247120" cy="4754880"/>
+        </p:xfrm>
+        <a:graphic>
+          <a:graphicData uri="http://schemas.openxmlformats.org/drawingml/2006/table">
+            <a:tbl>
+              <a:tblPr firstRow="1" bandRow="1">
+                <a:tableStyleId>{5C22544A-7EE6-4342-B048-85BDC9FD1C3A}</a:tableStyleId>
+              </a:tblPr>
+              <a:tblGrid>
+                <a:gridCol w="3749040"/>
+                <a:gridCol w="3749040"/>
+                <a:gridCol w="3749040"/>
+              </a:tblGrid>
+              <a:tr h="594360">
+                <a:tc>
+                  <a:txBody>
+                    <a:bodyPr wrap="square"/>
+                    <a:lstStyle/>
+                    <a:p>
+                      <a:pPr algn="l"/>
+                      <a:r>
+                        <a:rPr sz="1400" b="1">
+                          <a:solidFill>
+                            <a:srgbClr val="FFFFFF"/>
+                          </a:solidFill>
+                          <a:ea typeface="TH Sarabun New"/>
+                          <a:cs typeface="TH Sarabun New"/>
+                          <a:latin typeface="TH Sarabun New"/>
+                        </a:rPr>
+                        <a:t>คีย์</a:t>
+                      </a:r>
+                    </a:p>
+                  </a:txBody>
+                  <a:tcPr anchor="ctr">
+                    <a:solidFill>
+                      <a:srgbClr val="1D408C"/>
+                    </a:solidFill>
+                  </a:tcPr>
+                </a:tc>
+                <a:tc>
+                  <a:txBody>
+                    <a:bodyPr wrap="square"/>
+                    <a:lstStyle/>
+                    <a:p>
+                      <a:pPr algn="l"/>
+                      <a:r>
+                        <a:rPr sz="1400" b="1">
+                          <a:solidFill>
+                            <a:srgbClr val="FFFFFF"/>
+                          </a:solidFill>
+                          <a:ea typeface="TH Sarabun New"/>
+                          <a:cs typeface="TH Sarabun New"/>
+                          <a:latin typeface="TH Sarabun New"/>
+                        </a:rPr>
+                        <a:t>ชื่อ</a:t>
+                      </a:r>
+                    </a:p>
+                  </a:txBody>
+                  <a:tcPr anchor="ctr">
+                    <a:solidFill>
+                      <a:srgbClr val="1D408C"/>
+                    </a:solidFill>
+                  </a:tcPr>
+                </a:tc>
+                <a:tc>
+                  <a:txBody>
+                    <a:bodyPr wrap="square"/>
+                    <a:lstStyle/>
+                    <a:p>
+                      <a:pPr algn="l"/>
+                      <a:r>
+                        <a:rPr sz="1400" b="1">
+                          <a:solidFill>
+                            <a:srgbClr val="FFFFFF"/>
+                          </a:solidFill>
+                          <a:ea typeface="TH Sarabun New"/>
+                          <a:cs typeface="TH Sarabun New"/>
+                          <a:latin typeface="TH Sarabun New"/>
+                        </a:rPr>
+                        <a:t>ต้องคนยืนยัน</a:t>
+                      </a:r>
+                    </a:p>
+                  </a:txBody>
+                  <a:tcPr anchor="ctr">
+                    <a:solidFill>
+                      <a:srgbClr val="1D408C"/>
+                    </a:solidFill>
+                  </a:tcPr>
+                </a:tc>
+              </a:tr>
+              <a:tr h="594360">
+                <a:tc>
+                  <a:txBody>
+                    <a:bodyPr wrap="square"/>
+                    <a:lstStyle/>
+                    <a:p>
+                      <a:pPr algn="l"/>
+                      <a:r>
+                        <a:rPr sz="1300" b="0">
+                          <a:solidFill>
+                            <a:srgbClr val="1F2A37"/>
+                          </a:solidFill>
+                          <a:ea typeface="TH Sarabun New"/>
+                          <a:cs typeface="TH Sarabun New"/>
+                          <a:latin typeface="TH Sarabun New"/>
+                        </a:rPr>
+                        <a:t>s1 / s2</a:t>
+                      </a:r>
+                    </a:p>
+                  </a:txBody>
+                  <a:tcPr anchor="ctr">
+                    <a:solidFill>
+                      <a:srgbClr val="F4F7FB"/>
+                    </a:solidFill>
+                  </a:tcPr>
+                </a:tc>
+                <a:tc>
+                  <a:txBody>
+                    <a:bodyPr wrap="square"/>
+                    <a:lstStyle/>
+                    <a:p>
+                      <a:pPr algn="l"/>
+                      <a:r>
+                        <a:rPr sz="1300" b="0">
+                          <a:solidFill>
+                            <a:srgbClr val="1F2A37"/>
+                          </a:solidFill>
+                          <a:ea typeface="TH Sarabun New"/>
+                          <a:cs typeface="TH Sarabun New"/>
+                          <a:latin typeface="TH Sarabun New"/>
+                        </a:rPr>
+                        <a:t>ความเป็นมา / วัตถุประสงค์</a:t>
+                      </a:r>
+                    </a:p>
+                  </a:txBody>
+                  <a:tcPr anchor="ctr">
+                    <a:solidFill>
+                      <a:srgbClr val="F4F7FB"/>
+                    </a:solidFill>
+                  </a:tcPr>
+                </a:tc>
+                <a:tc>
+                  <a:txBody>
+                    <a:bodyPr wrap="square"/>
+                    <a:lstStyle/>
+                    <a:p>
+                      <a:pPr algn="l"/>
+                      <a:r>
+                        <a:rPr sz="1300" b="0">
+                          <a:solidFill>
+                            <a:srgbClr val="1F2A37"/>
+                          </a:solidFill>
+                          <a:ea typeface="TH Sarabun New"/>
+                          <a:cs typeface="TH Sarabun New"/>
+                          <a:latin typeface="TH Sarabun New"/>
+                        </a:rPr>
+                        <a:t>ไม่</a:t>
+                      </a:r>
+                    </a:p>
+                  </a:txBody>
+                  <a:tcPr anchor="ctr">
+                    <a:solidFill>
+                      <a:srgbClr val="F4F7FB"/>
+                    </a:solidFill>
+                  </a:tcPr>
+                </a:tc>
+              </a:tr>
+              <a:tr h="594360">
+                <a:tc>
+                  <a:txBody>
+                    <a:bodyPr wrap="square"/>
+                    <a:lstStyle/>
+                    <a:p>
+                      <a:pPr algn="l"/>
+                      <a:r>
+                        <a:rPr sz="1300" b="0">
+                          <a:solidFill>
+                            <a:srgbClr val="1F2A37"/>
+                          </a:solidFill>
+                          <a:ea typeface="TH Sarabun New"/>
+                          <a:cs typeface="TH Sarabun New"/>
+                          <a:latin typeface="TH Sarabun New"/>
+                        </a:rPr>
+                        <a:t>s3</a:t>
+                      </a:r>
+                    </a:p>
+                  </a:txBody>
+                  <a:tcPr anchor="ctr">
+                    <a:solidFill>
+                      <a:srgbClr val="FFFFFF"/>
+                    </a:solidFill>
+                  </a:tcPr>
+                </a:tc>
+                <a:tc>
+                  <a:txBody>
+                    <a:bodyPr wrap="square"/>
+                    <a:lstStyle/>
+                    <a:p>
+                      <a:pPr algn="l"/>
+                      <a:r>
+                        <a:rPr sz="1300" b="0">
+                          <a:solidFill>
+                            <a:srgbClr val="1F2A37"/>
+                          </a:solidFill>
+                          <a:ea typeface="TH Sarabun New"/>
+                          <a:cs typeface="TH Sarabun New"/>
+                          <a:latin typeface="TH Sarabun New"/>
+                        </a:rPr>
+                        <a:t>คุณสมบัติผู้เสนอราคา</a:t>
+                      </a:r>
+                    </a:p>
+                  </a:txBody>
+                  <a:tcPr anchor="ctr">
+                    <a:solidFill>
+                      <a:srgbClr val="FFFFFF"/>
+                    </a:solidFill>
+                  </a:tcPr>
+                </a:tc>
+                <a:tc>
+                  <a:txBody>
+                    <a:bodyPr wrap="square"/>
+                    <a:lstStyle/>
+                    <a:p>
+                      <a:pPr algn="l"/>
+                      <a:r>
+                        <a:rPr sz="1300" b="0">
+                          <a:solidFill>
+                            <a:srgbClr val="1F2A37"/>
+                          </a:solidFill>
+                          <a:ea typeface="TH Sarabun New"/>
+                          <a:cs typeface="TH Sarabun New"/>
+                          <a:latin typeface="TH Sarabun New"/>
+                        </a:rPr>
+                        <a:t>ใช่</a:t>
+                      </a:r>
+                    </a:p>
+                  </a:txBody>
+                  <a:tcPr anchor="ctr">
+                    <a:solidFill>
+                      <a:srgbClr val="FFFFFF"/>
+                    </a:solidFill>
+                  </a:tcPr>
+                </a:tc>
+              </a:tr>
+              <a:tr h="594360">
+                <a:tc>
+                  <a:txBody>
+                    <a:bodyPr wrap="square"/>
+                    <a:lstStyle/>
+                    <a:p>
+                      <a:pPr algn="l"/>
+                      <a:r>
+                        <a:rPr sz="1300" b="0">
+                          <a:solidFill>
+                            <a:srgbClr val="1F2A37"/>
+                          </a:solidFill>
+                          <a:ea typeface="TH Sarabun New"/>
+                          <a:cs typeface="TH Sarabun New"/>
+                          <a:latin typeface="TH Sarabun New"/>
+                        </a:rPr>
+                        <a:t>s4</a:t>
+                      </a:r>
+                    </a:p>
+                  </a:txBody>
+                  <a:tcPr anchor="ctr">
+                    <a:solidFill>
+                      <a:srgbClr val="F4F7FB"/>
+                    </a:solidFill>
+                  </a:tcPr>
+                </a:tc>
+                <a:tc>
+                  <a:txBody>
+                    <a:bodyPr wrap="square"/>
+                    <a:lstStyle/>
+                    <a:p>
+                      <a:pPr algn="l"/>
+                      <a:r>
+                        <a:rPr sz="1300" b="0">
+                          <a:solidFill>
+                            <a:srgbClr val="1F2A37"/>
+                          </a:solidFill>
+                          <a:ea typeface="TH Sarabun New"/>
+                          <a:cs typeface="TH Sarabun New"/>
+                          <a:latin typeface="TH Sarabun New"/>
+                        </a:rPr>
+                        <a:t>ขอบเขตงาน + s4.1–s4.14</a:t>
+                      </a:r>
+                    </a:p>
+                  </a:txBody>
+                  <a:tcPr anchor="ctr">
+                    <a:solidFill>
+                      <a:srgbClr val="F4F7FB"/>
+                    </a:solidFill>
+                  </a:tcPr>
+                </a:tc>
+                <a:tc>
+                  <a:txBody>
+                    <a:bodyPr wrap="square"/>
+                    <a:lstStyle/>
+                    <a:p>
+                      <a:pPr algn="l"/>
+                      <a:r>
+                        <a:rPr sz="1300" b="0">
+                          <a:solidFill>
+                            <a:srgbClr val="1F2A37"/>
+                          </a:solidFill>
+                          <a:ea typeface="TH Sarabun New"/>
+                          <a:cs typeface="TH Sarabun New"/>
+                          <a:latin typeface="TH Sarabun New"/>
+                        </a:rPr>
+                        <a:t>ไม่ (บังคับย่อย s4.1, s4.8)</a:t>
+                      </a:r>
+                    </a:p>
+                  </a:txBody>
+                  <a:tcPr anchor="ctr">
+                    <a:solidFill>
+                      <a:srgbClr val="F4F7FB"/>
+                    </a:solidFill>
+                  </a:tcPr>
+                </a:tc>
+              </a:tr>
+              <a:tr h="594360">
+                <a:tc>
+                  <a:txBody>
+                    <a:bodyPr wrap="square"/>
+                    <a:lstStyle/>
+                    <a:p>
+                      <a:pPr algn="l"/>
+                      <a:r>
+                        <a:rPr sz="1300" b="0">
+                          <a:solidFill>
+                            <a:srgbClr val="1F2A37"/>
+                          </a:solidFill>
+                          <a:ea typeface="TH Sarabun New"/>
+                          <a:cs typeface="TH Sarabun New"/>
+                          <a:latin typeface="TH Sarabun New"/>
+                        </a:rPr>
+                        <a:t>s5 / s7</a:t>
+                      </a:r>
+                    </a:p>
+                  </a:txBody>
+                  <a:tcPr anchor="ctr">
+                    <a:solidFill>
+                      <a:srgbClr val="FFFFFF"/>
+                    </a:solidFill>
+                  </a:tcPr>
+                </a:tc>
+                <a:tc>
+                  <a:txBody>
+                    <a:bodyPr wrap="square"/>
+                    <a:lstStyle/>
+                    <a:p>
+                      <a:pPr algn="l"/>
+                      <a:r>
+                        <a:rPr sz="1300" b="0">
+                          <a:solidFill>
+                            <a:srgbClr val="1F2A37"/>
+                          </a:solidFill>
+                          <a:ea typeface="TH Sarabun New"/>
+                          <a:cs typeface="TH Sarabun New"/>
+                          <a:latin typeface="TH Sarabun New"/>
+                        </a:rPr>
+                        <a:t>ระยะเวลา / สถานที่</a:t>
+                      </a:r>
+                    </a:p>
+                  </a:txBody>
+                  <a:tcPr anchor="ctr">
+                    <a:solidFill>
+                      <a:srgbClr val="FFFFFF"/>
+                    </a:solidFill>
+                  </a:tcPr>
+                </a:tc>
+                <a:tc>
+                  <a:txBody>
+                    <a:bodyPr wrap="square"/>
+                    <a:lstStyle/>
+                    <a:p>
+                      <a:pPr algn="l"/>
+                      <a:r>
+                        <a:rPr sz="1300" b="0">
+                          <a:solidFill>
+                            <a:srgbClr val="1F2A37"/>
+                          </a:solidFill>
+                          <a:ea typeface="TH Sarabun New"/>
+                          <a:cs typeface="TH Sarabun New"/>
+                          <a:latin typeface="TH Sarabun New"/>
+                        </a:rPr>
+                        <a:t>ไม่</a:t>
+                      </a:r>
+                    </a:p>
+                  </a:txBody>
+                  <a:tcPr anchor="ctr">
+                    <a:solidFill>
+                      <a:srgbClr val="FFFFFF"/>
+                    </a:solidFill>
+                  </a:tcPr>
+                </a:tc>
+              </a:tr>
+              <a:tr h="594360">
+                <a:tc>
+                  <a:txBody>
+                    <a:bodyPr wrap="square"/>
+                    <a:lstStyle/>
+                    <a:p>
+                      <a:pPr algn="l"/>
+                      <a:r>
+                        <a:rPr sz="1300" b="0">
+                          <a:solidFill>
+                            <a:srgbClr val="1F2A37"/>
+                          </a:solidFill>
+                          <a:ea typeface="TH Sarabun New"/>
+                          <a:cs typeface="TH Sarabun New"/>
+                          <a:latin typeface="TH Sarabun New"/>
+                        </a:rPr>
+                        <a:t>s6 / s8</a:t>
+                      </a:r>
+                    </a:p>
+                  </a:txBody>
+                  <a:tcPr anchor="ctr">
+                    <a:solidFill>
+                      <a:srgbClr val="F4F7FB"/>
+                    </a:solidFill>
+                  </a:tcPr>
+                </a:tc>
+                <a:tc>
+                  <a:txBody>
+                    <a:bodyPr wrap="square"/>
+                    <a:lstStyle/>
+                    <a:p>
+                      <a:pPr algn="l"/>
+                      <a:r>
+                        <a:rPr sz="1300" b="0">
+                          <a:solidFill>
+                            <a:srgbClr val="1F2A37"/>
+                          </a:solidFill>
+                          <a:ea typeface="TH Sarabun New"/>
+                          <a:cs typeface="TH Sarabun New"/>
+                          <a:latin typeface="TH Sarabun New"/>
+                        </a:rPr>
+                        <a:t>งบประมาณ / งวดจ่าย</a:t>
+                      </a:r>
+                    </a:p>
+                  </a:txBody>
+                  <a:tcPr anchor="ctr">
+                    <a:solidFill>
+                      <a:srgbClr val="F4F7FB"/>
+                    </a:solidFill>
+                  </a:tcPr>
+                </a:tc>
+                <a:tc>
+                  <a:txBody>
+                    <a:bodyPr wrap="square"/>
+                    <a:lstStyle/>
+                    <a:p>
+                      <a:pPr algn="l"/>
+                      <a:r>
+                        <a:rPr sz="1300" b="0">
+                          <a:solidFill>
+                            <a:srgbClr val="1F2A37"/>
+                          </a:solidFill>
+                          <a:ea typeface="TH Sarabun New"/>
+                          <a:cs typeface="TH Sarabun New"/>
+                          <a:latin typeface="TH Sarabun New"/>
+                        </a:rPr>
+                        <a:t>ใช่</a:t>
+                      </a:r>
+                    </a:p>
+                  </a:txBody>
+                  <a:tcPr anchor="ctr">
+                    <a:solidFill>
+                      <a:srgbClr val="F4F7FB"/>
+                    </a:solidFill>
+                  </a:tcPr>
+                </a:tc>
+              </a:tr>
+              <a:tr h="594360">
+                <a:tc>
+                  <a:txBody>
+                    <a:bodyPr wrap="square"/>
+                    <a:lstStyle/>
+                    <a:p>
+                      <a:pPr algn="l"/>
+                      <a:r>
+                        <a:rPr sz="1300" b="0">
+                          <a:solidFill>
+                            <a:srgbClr val="1F2A37"/>
+                          </a:solidFill>
+                          <a:ea typeface="TH Sarabun New"/>
+                          <a:cs typeface="TH Sarabun New"/>
+                          <a:latin typeface="TH Sarabun New"/>
+                        </a:rPr>
+                        <a:t>s9 / s11 / s12</a:t>
+                      </a:r>
+                    </a:p>
+                  </a:txBody>
+                  <a:tcPr anchor="ctr">
+                    <a:solidFill>
+                      <a:srgbClr val="FFFFFF"/>
+                    </a:solidFill>
+                  </a:tcPr>
+                </a:tc>
+                <a:tc>
+                  <a:txBody>
+                    <a:bodyPr wrap="square"/>
+                    <a:lstStyle/>
+                    <a:p>
+                      <a:pPr algn="l"/>
+                      <a:r>
+                        <a:rPr sz="1300" b="0">
+                          <a:solidFill>
+                            <a:srgbClr val="1F2A37"/>
+                          </a:solidFill>
+                          <a:ea typeface="TH Sarabun New"/>
+                          <a:cs typeface="TH Sarabun New"/>
+                          <a:latin typeface="TH Sarabun New"/>
+                        </a:rPr>
+                        <a:t>รับประกัน / เกณฑ์ / เอกสารยื่น</a:t>
+                      </a:r>
+                    </a:p>
+                  </a:txBody>
+                  <a:tcPr anchor="ctr">
+                    <a:solidFill>
+                      <a:srgbClr val="FFFFFF"/>
+                    </a:solidFill>
+                  </a:tcPr>
+                </a:tc>
+                <a:tc>
+                  <a:txBody>
+                    <a:bodyPr wrap="square"/>
+                    <a:lstStyle/>
+                    <a:p>
+                      <a:pPr algn="l"/>
+                      <a:r>
+                        <a:rPr sz="1300" b="0">
+                          <a:solidFill>
+                            <a:srgbClr val="1F2A37"/>
+                          </a:solidFill>
+                          <a:ea typeface="TH Sarabun New"/>
+                          <a:cs typeface="TH Sarabun New"/>
+                          <a:latin typeface="TH Sarabun New"/>
+                        </a:rPr>
+                        <a:t>ไม่</a:t>
+                      </a:r>
+                    </a:p>
+                  </a:txBody>
+                  <a:tcPr anchor="ctr">
+                    <a:solidFill>
+                      <a:srgbClr val="FFFFFF"/>
+                    </a:solidFill>
+                  </a:tcPr>
+                </a:tc>
+              </a:tr>
+              <a:tr h="594360">
+                <a:tc>
+                  <a:txBody>
+                    <a:bodyPr wrap="square"/>
+                    <a:lstStyle/>
+                    <a:p>
+                      <a:pPr algn="l"/>
+                      <a:r>
+                        <a:rPr sz="1300" b="0">
+                          <a:solidFill>
+                            <a:srgbClr val="1F2A37"/>
+                          </a:solidFill>
+                          <a:ea typeface="TH Sarabun New"/>
+                          <a:cs typeface="TH Sarabun New"/>
+                          <a:latin typeface="TH Sarabun New"/>
+                        </a:rPr>
+                        <a:t>s10 / s13</a:t>
+                      </a:r>
+                    </a:p>
+                  </a:txBody>
+                  <a:tcPr anchor="ctr">
+                    <a:solidFill>
+                      <a:srgbClr val="F4F7FB"/>
+                    </a:solidFill>
+                  </a:tcPr>
+                </a:tc>
+                <a:tc>
+                  <a:txBody>
+                    <a:bodyPr wrap="square"/>
+                    <a:lstStyle/>
+                    <a:p>
+                      <a:pPr algn="l"/>
+                      <a:r>
+                        <a:rPr sz="1300" b="0">
+                          <a:solidFill>
+                            <a:srgbClr val="1F2A37"/>
+                          </a:solidFill>
+                          <a:ea typeface="TH Sarabun New"/>
+                          <a:cs typeface="TH Sarabun New"/>
+                          <a:latin typeface="TH Sarabun New"/>
+                        </a:rPr>
+                        <a:t>ค่าปรับ / เงื่อนไขอื่น</a:t>
+                      </a:r>
+                    </a:p>
+                  </a:txBody>
+                  <a:tcPr anchor="ctr">
+                    <a:solidFill>
+                      <a:srgbClr val="F4F7FB"/>
+                    </a:solidFill>
+                  </a:tcPr>
+                </a:tc>
+                <a:tc>
+                  <a:txBody>
+                    <a:bodyPr wrap="square"/>
+                    <a:lstStyle/>
+                    <a:p>
+                      <a:pPr algn="l"/>
+                      <a:r>
+                        <a:rPr sz="1300" b="0">
+                          <a:solidFill>
+                            <a:srgbClr val="1F2A37"/>
+                          </a:solidFill>
+                          <a:ea typeface="TH Sarabun New"/>
+                          <a:cs typeface="TH Sarabun New"/>
+                          <a:latin typeface="TH Sarabun New"/>
+                        </a:rPr>
+                        <a:t>ใช่</a:t>
+                      </a:r>
+                    </a:p>
+                  </a:txBody>
+                  <a:tcPr anchor="ctr">
+                    <a:solidFill>
+                      <a:srgbClr val="F4F7FB"/>
+                    </a:solidFill>
+                  </a:tcPr>
+                </a:tc>
+              </a:tr>
+            </a:tbl>
+          </a:graphicData>
+        </a:graphic>
+      </p:graphicFrame>
+    </p:spTree>
+  </p:cSld>
+  <p:clrMapOvr>
+    <a:masterClrMapping/>
+  </p:clrMapOvr>
+</p:sld>
+</file>
+
+<file path=ppt/slides/slide11.xml><?xml version="1.0" encoding="utf-8"?>
+<p:sld xmlns:a="http://schemas.openxmlformats.org/drawingml/2006/main" xmlns:p="http://schemas.openxmlformats.org/presentationml/2006/main" xmlns:r="http://schemas.openxmlformats.org/officeDocument/2006/relationships">
+  <p:cSld>
+    <p:spTree>
+      <p:nvGrpSpPr>
+        <p:cNvPr id="1" name=""/>
+        <p:cNvGrpSpPr/>
+        <p:nvPr/>
+      </p:nvGrpSpPr>
+      <p:grpSpPr/>
+      <p:sp>
+        <p:nvSpPr>
+          <p:cNvPr id="2" name="Rectangle 1"/>
+          <p:cNvSpPr/>
+          <p:nvPr/>
+        </p:nvSpPr>
+        <p:spPr>
+          <a:xfrm>
+            <a:off x="0" y="0"/>
+            <a:ext cx="12191695" cy="6858000"/>
+          </a:xfrm>
+          <a:prstGeom prst="rect">
+            <a:avLst/>
+          </a:prstGeom>
+          <a:solidFill>
+            <a:srgbClr val="FFFFFF"/>
+          </a:solidFill>
+          <a:ln>
+            <a:noFill/>
+          </a:ln>
+        </p:spPr>
+        <p:style>
+          <a:lnRef idx="1">
+            <a:schemeClr val="accent1"/>
+          </a:lnRef>
+          <a:fillRef idx="3">
+            <a:schemeClr val="accent1"/>
+          </a:fillRef>
+          <a:effectRef idx="2">
+            <a:schemeClr val="accent1"/>
+          </a:effectRef>
+          <a:fontRef idx="minor">
+            <a:schemeClr val="lt1"/>
+          </a:fontRef>
+        </p:style>
+        <p:txBody>
+          <a:bodyPr rtlCol="0" anchor="ctr"/>
+          <a:lstStyle/>
+          <a:p>
+            <a:pPr algn="ctr"/>
+          </a:p>
+        </p:txBody>
+      </p:sp>
+      <p:sp>
+        <p:nvSpPr>
+          <p:cNvPr id="3" name="Rectangle 2"/>
+          <p:cNvSpPr/>
+          <p:nvPr/>
+        </p:nvSpPr>
+        <p:spPr>
+          <a:xfrm>
+            <a:off x="0" y="0"/>
+            <a:ext cx="12191695" cy="109728"/>
+          </a:xfrm>
+          <a:prstGeom prst="rect">
+            <a:avLst/>
+          </a:prstGeom>
+          <a:solidFill>
+            <a:srgbClr val="F2A30A"/>
+          </a:solidFill>
+          <a:ln>
+            <a:noFill/>
+          </a:ln>
+        </p:spPr>
+        <p:style>
+          <a:lnRef idx="1">
+            <a:schemeClr val="accent1"/>
+          </a:lnRef>
+          <a:fillRef idx="3">
+            <a:schemeClr val="accent1"/>
+          </a:fillRef>
+          <a:effectRef idx="2">
+            <a:schemeClr val="accent1"/>
+          </a:effectRef>
+          <a:fontRef idx="minor">
+            <a:schemeClr val="lt1"/>
+          </a:fontRef>
+        </p:style>
+        <p:txBody>
+          <a:bodyPr rtlCol="0" anchor="ctr"/>
+          <a:lstStyle/>
+          <a:p>
+            <a:pPr algn="ctr"/>
+          </a:p>
+        </p:txBody>
+      </p:sp>
+      <p:sp>
+        <p:nvSpPr>
+          <p:cNvPr id="4" name="Rectangle 3"/>
+          <p:cNvSpPr/>
+          <p:nvPr/>
+        </p:nvSpPr>
+        <p:spPr>
+          <a:xfrm>
+            <a:off x="0" y="6583680"/>
+            <a:ext cx="12191695" cy="274320"/>
+          </a:xfrm>
+          <a:prstGeom prst="rect">
+            <a:avLst/>
+          </a:prstGeom>
+          <a:solidFill>
+            <a:srgbClr val="0F233E"/>
+          </a:solidFill>
+          <a:ln>
+            <a:noFill/>
+          </a:ln>
+        </p:spPr>
+        <p:style>
+          <a:lnRef idx="1">
+            <a:schemeClr val="accent1"/>
+          </a:lnRef>
+          <a:fillRef idx="3">
+            <a:schemeClr val="accent1"/>
+          </a:fillRef>
+          <a:effectRef idx="2">
+            <a:schemeClr val="accent1"/>
+          </a:effectRef>
+          <a:fontRef idx="minor">
+            <a:schemeClr val="lt1"/>
+          </a:fontRef>
+        </p:style>
+        <p:txBody>
+          <a:bodyPr rtlCol="0" anchor="ctr" wrap="none"/>
+          <a:lstStyle/>
+          <a:p>
+            <a:pPr algn="r"/>
+            <a:r>
+              <a:rPr sz="1200" b="0">
+                <a:solidFill>
+                  <a:srgbClr val="FFFFFF"/>
+                </a:solidFill>
+                <a:ea typeface="TH Sarabun New"/>
+                <a:cs typeface="TH Sarabun New"/>
+                <a:latin typeface="TH Sarabun New"/>
+              </a:rPr>
+              <a:t>TOR Generator  v0.2.3   ·   รายงานการทำงาน   ·   20 ส.ค. 2026</a:t>
+            </a:r>
+          </a:p>
+        </p:txBody>
+      </p:sp>
+      <p:sp>
+        <p:nvSpPr>
+          <p:cNvPr id="5" name="TextBox 4"/>
+          <p:cNvSpPr txBox="1"/>
+          <p:nvPr/>
+        </p:nvSpPr>
+        <p:spPr>
+          <a:xfrm>
+            <a:off x="457200" y="256032"/>
+            <a:ext cx="11247120" cy="457200"/>
+          </a:xfrm>
+          <a:prstGeom prst="rect">
+            <a:avLst/>
+          </a:prstGeom>
+          <a:noFill/>
+        </p:spPr>
+        <p:txBody>
+          <a:bodyPr wrap="square">
+            <a:spAutoFit/>
+          </a:bodyPr>
+          <a:lstStyle/>
+          <a:p>
+            <a:pPr algn="l"/>
+            <a:r>
+              <a:rPr sz="2600" b="1">
+                <a:solidFill>
+                  <a:srgbClr val="1D408C"/>
+                </a:solidFill>
+                <a:ea typeface="TH Sarabun New"/>
+                <a:cs typeface="TH Sarabun New"/>
+                <a:latin typeface="TH Sarabun New"/>
+              </a:rPr>
               <a:t>Workflow หลัก — 5 Phase</a:t>
             </a:r>
           </a:p>
@@ -3571,7 +4410,7 @@
 </p:sld>
 </file>
 
-<file path=ppt/slides/slide11.xml><?xml version="1.0" encoding="utf-8"?>
+<file path=ppt/slides/slide12.xml><?xml version="1.0" encoding="utf-8"?>
 <p:sld xmlns:a="http://schemas.openxmlformats.org/drawingml/2006/main" xmlns:p="http://schemas.openxmlformats.org/presentationml/2006/main" xmlns:r="http://schemas.openxmlformats.org/officeDocument/2006/relationships">
   <p:cSld>
     <p:spTree>
@@ -4255,7 +5094,7 @@
 </p:sld>
 </file>
 
-<file path=ppt/slides/slide12.xml><?xml version="1.0" encoding="utf-8"?>
+<file path=ppt/slides/slide13.xml><?xml version="1.0" encoding="utf-8"?>
 <p:sld xmlns:a="http://schemas.openxmlformats.org/drawingml/2006/main" xmlns:p="http://schemas.openxmlformats.org/presentationml/2006/main" xmlns:r="http://schemas.openxmlformats.org/officeDocument/2006/relationships">
   <p:cSld>
     <p:spTree>
@@ -4459,7 +5298,7 @@
         <p:spPr>
           <a:xfrm>
             <a:off x="320040" y="868680"/>
-            <a:ext cx="5669280" cy="9433052"/>
+            <a:ext cx="5669280" cy="9496541"/>
           </a:xfrm>
           <a:prstGeom prst="rect">
             <a:avLst/>
@@ -4483,7 +5322,7 @@
         <p:spPr>
           <a:xfrm>
             <a:off x="6217920" y="868680"/>
-            <a:ext cx="5577840" cy="6821234"/>
+            <a:ext cx="5577840" cy="6885207"/>
           </a:xfrm>
           <a:prstGeom prst="rect">
             <a:avLst/>
@@ -4560,384 +5399,6 @@
                 <a:latin typeface="TH Sarabun New"/>
               </a:rPr>
               <a:t>Phase 1 ความครบ</a:t>
-            </a:r>
-          </a:p>
-        </p:txBody>
-      </p:sp>
-    </p:spTree>
-  </p:cSld>
-  <p:clrMapOvr>
-    <a:masterClrMapping/>
-  </p:clrMapOvr>
-</p:sld>
-</file>
-
-<file path=ppt/slides/slide13.xml><?xml version="1.0" encoding="utf-8"?>
-<p:sld xmlns:a="http://schemas.openxmlformats.org/drawingml/2006/main" xmlns:p="http://schemas.openxmlformats.org/presentationml/2006/main" xmlns:r="http://schemas.openxmlformats.org/officeDocument/2006/relationships">
-  <p:cSld>
-    <p:spTree>
-      <p:nvGrpSpPr>
-        <p:cNvPr id="1" name=""/>
-        <p:cNvGrpSpPr/>
-        <p:nvPr/>
-      </p:nvGrpSpPr>
-      <p:grpSpPr/>
-      <p:sp>
-        <p:nvSpPr>
-          <p:cNvPr id="2" name="Rectangle 1"/>
-          <p:cNvSpPr/>
-          <p:nvPr/>
-        </p:nvSpPr>
-        <p:spPr>
-          <a:xfrm>
-            <a:off x="0" y="0"/>
-            <a:ext cx="12191695" cy="6858000"/>
-          </a:xfrm>
-          <a:prstGeom prst="rect">
-            <a:avLst/>
-          </a:prstGeom>
-          <a:solidFill>
-            <a:srgbClr val="FFFFFF"/>
-          </a:solidFill>
-          <a:ln>
-            <a:noFill/>
-          </a:ln>
-        </p:spPr>
-        <p:style>
-          <a:lnRef idx="1">
-            <a:schemeClr val="accent1"/>
-          </a:lnRef>
-          <a:fillRef idx="3">
-            <a:schemeClr val="accent1"/>
-          </a:fillRef>
-          <a:effectRef idx="2">
-            <a:schemeClr val="accent1"/>
-          </a:effectRef>
-          <a:fontRef idx="minor">
-            <a:schemeClr val="lt1"/>
-          </a:fontRef>
-        </p:style>
-        <p:txBody>
-          <a:bodyPr rtlCol="0" anchor="ctr"/>
-          <a:lstStyle/>
-          <a:p>
-            <a:pPr algn="ctr"/>
-          </a:p>
-        </p:txBody>
-      </p:sp>
-      <p:sp>
-        <p:nvSpPr>
-          <p:cNvPr id="3" name="Rectangle 2"/>
-          <p:cNvSpPr/>
-          <p:nvPr/>
-        </p:nvSpPr>
-        <p:spPr>
-          <a:xfrm>
-            <a:off x="0" y="0"/>
-            <a:ext cx="12191695" cy="109728"/>
-          </a:xfrm>
-          <a:prstGeom prst="rect">
-            <a:avLst/>
-          </a:prstGeom>
-          <a:solidFill>
-            <a:srgbClr val="F2A30A"/>
-          </a:solidFill>
-          <a:ln>
-            <a:noFill/>
-          </a:ln>
-        </p:spPr>
-        <p:style>
-          <a:lnRef idx="1">
-            <a:schemeClr val="accent1"/>
-          </a:lnRef>
-          <a:fillRef idx="3">
-            <a:schemeClr val="accent1"/>
-          </a:fillRef>
-          <a:effectRef idx="2">
-            <a:schemeClr val="accent1"/>
-          </a:effectRef>
-          <a:fontRef idx="minor">
-            <a:schemeClr val="lt1"/>
-          </a:fontRef>
-        </p:style>
-        <p:txBody>
-          <a:bodyPr rtlCol="0" anchor="ctr"/>
-          <a:lstStyle/>
-          <a:p>
-            <a:pPr algn="ctr"/>
-          </a:p>
-        </p:txBody>
-      </p:sp>
-      <p:sp>
-        <p:nvSpPr>
-          <p:cNvPr id="4" name="Rectangle 3"/>
-          <p:cNvSpPr/>
-          <p:nvPr/>
-        </p:nvSpPr>
-        <p:spPr>
-          <a:xfrm>
-            <a:off x="0" y="6583680"/>
-            <a:ext cx="12191695" cy="274320"/>
-          </a:xfrm>
-          <a:prstGeom prst="rect">
-            <a:avLst/>
-          </a:prstGeom>
-          <a:solidFill>
-            <a:srgbClr val="0F233E"/>
-          </a:solidFill>
-          <a:ln>
-            <a:noFill/>
-          </a:ln>
-        </p:spPr>
-        <p:style>
-          <a:lnRef idx="1">
-            <a:schemeClr val="accent1"/>
-          </a:lnRef>
-          <a:fillRef idx="3">
-            <a:schemeClr val="accent1"/>
-          </a:fillRef>
-          <a:effectRef idx="2">
-            <a:schemeClr val="accent1"/>
-          </a:effectRef>
-          <a:fontRef idx="minor">
-            <a:schemeClr val="lt1"/>
-          </a:fontRef>
-        </p:style>
-        <p:txBody>
-          <a:bodyPr rtlCol="0" anchor="ctr" wrap="none"/>
-          <a:lstStyle/>
-          <a:p>
-            <a:pPr algn="r"/>
-            <a:r>
-              <a:rPr sz="1200" b="0">
-                <a:solidFill>
-                  <a:srgbClr val="FFFFFF"/>
-                </a:solidFill>
-                <a:ea typeface="TH Sarabun New"/>
-                <a:cs typeface="TH Sarabun New"/>
-                <a:latin typeface="TH Sarabun New"/>
-              </a:rPr>
-              <a:t>TOR Generator  v0.2.3   ·   รายงานการทำงาน   ·   20 ส.ค. 2026</a:t>
-            </a:r>
-          </a:p>
-        </p:txBody>
-      </p:sp>
-      <p:sp>
-        <p:nvSpPr>
-          <p:cNvPr id="5" name="TextBox 4"/>
-          <p:cNvSpPr txBox="1"/>
-          <p:nvPr/>
-        </p:nvSpPr>
-        <p:spPr>
-          <a:xfrm>
-            <a:off x="457200" y="256032"/>
-            <a:ext cx="11247120" cy="457200"/>
-          </a:xfrm>
-          <a:prstGeom prst="rect">
-            <a:avLst/>
-          </a:prstGeom>
-          <a:noFill/>
-        </p:spPr>
-        <p:txBody>
-          <a:bodyPr wrap="square">
-            <a:spAutoFit/>
-          </a:bodyPr>
-          <a:lstStyle/>
-          <a:p>
-            <a:pPr algn="l"/>
-            <a:r>
-              <a:rPr sz="2600" b="1">
-                <a:solidFill>
-                  <a:srgbClr val="1D408C"/>
-                </a:solidFill>
-                <a:ea typeface="TH Sarabun New"/>
-                <a:cs typeface="TH Sarabun New"/>
-                <a:latin typeface="TH Sarabun New"/>
-              </a:rPr>
-              <a:t>ภาพการใช้งาน Phase 2–4</a:t>
-            </a:r>
-          </a:p>
-        </p:txBody>
-      </p:sp>
-      <p:pic>
-        <p:nvPicPr>
-          <p:cNvPr id="6" name="Picture 5" descr="05-phase-2-draft.png"/>
-          <p:cNvPicPr>
-            <a:picLocks noChangeAspect="1"/>
-          </p:cNvPicPr>
-          <p:nvPr/>
-        </p:nvPicPr>
-        <p:blipFill>
-          <a:blip r:embed="rId2"/>
-          <a:stretch>
-            <a:fillRect/>
-          </a:stretch>
-        </p:blipFill>
-        <p:spPr>
-          <a:xfrm>
-            <a:off x="274320" y="868680"/>
-            <a:ext cx="3840480" cy="5384757"/>
-          </a:xfrm>
-          <a:prstGeom prst="rect">
-            <a:avLst/>
-          </a:prstGeom>
-        </p:spPr>
-      </p:pic>
-      <p:pic>
-        <p:nvPicPr>
-          <p:cNvPr id="7" name="Picture 6" descr="06-phase-3-review.png"/>
-          <p:cNvPicPr>
-            <a:picLocks noChangeAspect="1"/>
-          </p:cNvPicPr>
-          <p:nvPr/>
-        </p:nvPicPr>
-        <p:blipFill>
-          <a:blip r:embed="rId3"/>
-          <a:stretch>
-            <a:fillRect/>
-          </a:stretch>
-        </p:blipFill>
-        <p:spPr>
-          <a:xfrm>
-            <a:off x="4160520" y="868680"/>
-            <a:ext cx="3840480" cy="2400300"/>
-          </a:xfrm>
-          <a:prstGeom prst="rect">
-            <a:avLst/>
-          </a:prstGeom>
-        </p:spPr>
-      </p:pic>
-      <p:pic>
-        <p:nvPicPr>
-          <p:cNvPr id="8" name="Picture 7" descr="07-phase-4-publish.png"/>
-          <p:cNvPicPr>
-            <a:picLocks noChangeAspect="1"/>
-          </p:cNvPicPr>
-          <p:nvPr/>
-        </p:nvPicPr>
-        <p:blipFill>
-          <a:blip r:embed="rId4"/>
-          <a:stretch>
-            <a:fillRect/>
-          </a:stretch>
-        </p:blipFill>
-        <p:spPr>
-          <a:xfrm>
-            <a:off x="8046720" y="868680"/>
-            <a:ext cx="3840480" cy="2400300"/>
-          </a:xfrm>
-          <a:prstGeom prst="rect">
-            <a:avLst/>
-          </a:prstGeom>
-        </p:spPr>
-      </p:pic>
-      <p:sp>
-        <p:nvSpPr>
-          <p:cNvPr id="9" name="TextBox 8"/>
-          <p:cNvSpPr txBox="1"/>
-          <p:nvPr/>
-        </p:nvSpPr>
-        <p:spPr>
-          <a:xfrm>
-            <a:off x="274320" y="5943600"/>
-            <a:ext cx="3840480" cy="365760"/>
-          </a:xfrm>
-          <a:prstGeom prst="rect">
-            <a:avLst/>
-          </a:prstGeom>
-          <a:noFill/>
-        </p:spPr>
-        <p:txBody>
-          <a:bodyPr wrap="square">
-            <a:spAutoFit/>
-          </a:bodyPr>
-          <a:lstStyle/>
-          <a:p>
-            <a:pPr algn="ctr"/>
-            <a:r>
-              <a:rPr sz="1300" b="0">
-                <a:solidFill>
-                  <a:srgbClr val="5B6775"/>
-                </a:solidFill>
-                <a:ea typeface="TH Sarabun New"/>
-                <a:cs typeface="TH Sarabun New"/>
-                <a:latin typeface="TH Sarabun New"/>
-              </a:rPr>
-              <a:t>ร่าง + HITL</a:t>
-            </a:r>
-          </a:p>
-        </p:txBody>
-      </p:sp>
-      <p:sp>
-        <p:nvSpPr>
-          <p:cNvPr id="10" name="TextBox 9"/>
-          <p:cNvSpPr txBox="1"/>
-          <p:nvPr/>
-        </p:nvSpPr>
-        <p:spPr>
-          <a:xfrm>
-            <a:off x="4160520" y="5943600"/>
-            <a:ext cx="3840480" cy="365760"/>
-          </a:xfrm>
-          <a:prstGeom prst="rect">
-            <a:avLst/>
-          </a:prstGeom>
-          <a:noFill/>
-        </p:spPr>
-        <p:txBody>
-          <a:bodyPr wrap="square">
-            <a:spAutoFit/>
-          </a:bodyPr>
-          <a:lstStyle/>
-          <a:p>
-            <a:pPr algn="ctr"/>
-            <a:r>
-              <a:rPr sz="1300" b="0">
-                <a:solidFill>
-                  <a:srgbClr val="5B6775"/>
-                </a:solidFill>
-                <a:ea typeface="TH Sarabun New"/>
-                <a:cs typeface="TH Sarabun New"/>
-                <a:latin typeface="TH Sarabun New"/>
-              </a:rPr>
-              <a:t>ตรวจคะแนน</a:t>
-            </a:r>
-          </a:p>
-        </p:txBody>
-      </p:sp>
-      <p:sp>
-        <p:nvSpPr>
-          <p:cNvPr id="11" name="TextBox 10"/>
-          <p:cNvSpPr txBox="1"/>
-          <p:nvPr/>
-        </p:nvSpPr>
-        <p:spPr>
-          <a:xfrm>
-            <a:off x="8046720" y="5943600"/>
-            <a:ext cx="3840480" cy="365760"/>
-          </a:xfrm>
-          <a:prstGeom prst="rect">
-            <a:avLst/>
-          </a:prstGeom>
-          <a:noFill/>
-        </p:spPr>
-        <p:txBody>
-          <a:bodyPr wrap="square">
-            <a:spAutoFit/>
-          </a:bodyPr>
-          <a:lstStyle/>
-          <a:p>
-            <a:pPr algn="ctr"/>
-            <a:r>
-              <a:rPr sz="1300" b="0">
-                <a:solidFill>
-                  <a:srgbClr val="5B6775"/>
-                </a:solidFill>
-                <a:ea typeface="TH Sarabun New"/>
-                <a:cs typeface="TH Sarabun New"/>
-                <a:latin typeface="TH Sarabun New"/>
-              </a:rPr>
-              <a:t>ส่งออก</a:t>
             </a:r>
           </a:p>
         </p:txBody>
@@ -5132,6 +5593,384 @@
                 <a:cs typeface="TH Sarabun New"/>
                 <a:latin typeface="TH Sarabun New"/>
               </a:rPr>
+              <a:t>ภาพการใช้งาน Phase 2–4</a:t>
+            </a:r>
+          </a:p>
+        </p:txBody>
+      </p:sp>
+      <p:pic>
+        <p:nvPicPr>
+          <p:cNvPr id="6" name="Picture 5" descr="05-phase-2-draft.png"/>
+          <p:cNvPicPr>
+            <a:picLocks noChangeAspect="1"/>
+          </p:cNvPicPr>
+          <p:nvPr/>
+        </p:nvPicPr>
+        <p:blipFill>
+          <a:blip r:embed="rId2"/>
+          <a:stretch>
+            <a:fillRect/>
+          </a:stretch>
+        </p:blipFill>
+        <p:spPr>
+          <a:xfrm>
+            <a:off x="274320" y="868680"/>
+            <a:ext cx="3840480" cy="5384757"/>
+          </a:xfrm>
+          <a:prstGeom prst="rect">
+            <a:avLst/>
+          </a:prstGeom>
+        </p:spPr>
+      </p:pic>
+      <p:pic>
+        <p:nvPicPr>
+          <p:cNvPr id="7" name="Picture 6" descr="06-phase-3-review.png"/>
+          <p:cNvPicPr>
+            <a:picLocks noChangeAspect="1"/>
+          </p:cNvPicPr>
+          <p:nvPr/>
+        </p:nvPicPr>
+        <p:blipFill>
+          <a:blip r:embed="rId3"/>
+          <a:stretch>
+            <a:fillRect/>
+          </a:stretch>
+        </p:blipFill>
+        <p:spPr>
+          <a:xfrm>
+            <a:off x="4160520" y="868680"/>
+            <a:ext cx="3840480" cy="2400300"/>
+          </a:xfrm>
+          <a:prstGeom prst="rect">
+            <a:avLst/>
+          </a:prstGeom>
+        </p:spPr>
+      </p:pic>
+      <p:pic>
+        <p:nvPicPr>
+          <p:cNvPr id="8" name="Picture 7" descr="07-phase-4-publish.png"/>
+          <p:cNvPicPr>
+            <a:picLocks noChangeAspect="1"/>
+          </p:cNvPicPr>
+          <p:nvPr/>
+        </p:nvPicPr>
+        <p:blipFill>
+          <a:blip r:embed="rId4"/>
+          <a:stretch>
+            <a:fillRect/>
+          </a:stretch>
+        </p:blipFill>
+        <p:spPr>
+          <a:xfrm>
+            <a:off x="8046720" y="868680"/>
+            <a:ext cx="3840480" cy="2400300"/>
+          </a:xfrm>
+          <a:prstGeom prst="rect">
+            <a:avLst/>
+          </a:prstGeom>
+        </p:spPr>
+      </p:pic>
+      <p:sp>
+        <p:nvSpPr>
+          <p:cNvPr id="9" name="TextBox 8"/>
+          <p:cNvSpPr txBox="1"/>
+          <p:nvPr/>
+        </p:nvSpPr>
+        <p:spPr>
+          <a:xfrm>
+            <a:off x="274320" y="5943600"/>
+            <a:ext cx="3840480" cy="365760"/>
+          </a:xfrm>
+          <a:prstGeom prst="rect">
+            <a:avLst/>
+          </a:prstGeom>
+          <a:noFill/>
+        </p:spPr>
+        <p:txBody>
+          <a:bodyPr wrap="square">
+            <a:spAutoFit/>
+          </a:bodyPr>
+          <a:lstStyle/>
+          <a:p>
+            <a:pPr algn="ctr"/>
+            <a:r>
+              <a:rPr sz="1300" b="0">
+                <a:solidFill>
+                  <a:srgbClr val="5B6775"/>
+                </a:solidFill>
+                <a:ea typeface="TH Sarabun New"/>
+                <a:cs typeface="TH Sarabun New"/>
+                <a:latin typeface="TH Sarabun New"/>
+              </a:rPr>
+              <a:t>ร่าง + HITL</a:t>
+            </a:r>
+          </a:p>
+        </p:txBody>
+      </p:sp>
+      <p:sp>
+        <p:nvSpPr>
+          <p:cNvPr id="10" name="TextBox 9"/>
+          <p:cNvSpPr txBox="1"/>
+          <p:nvPr/>
+        </p:nvSpPr>
+        <p:spPr>
+          <a:xfrm>
+            <a:off x="4160520" y="5943600"/>
+            <a:ext cx="3840480" cy="365760"/>
+          </a:xfrm>
+          <a:prstGeom prst="rect">
+            <a:avLst/>
+          </a:prstGeom>
+          <a:noFill/>
+        </p:spPr>
+        <p:txBody>
+          <a:bodyPr wrap="square">
+            <a:spAutoFit/>
+          </a:bodyPr>
+          <a:lstStyle/>
+          <a:p>
+            <a:pPr algn="ctr"/>
+            <a:r>
+              <a:rPr sz="1300" b="0">
+                <a:solidFill>
+                  <a:srgbClr val="5B6775"/>
+                </a:solidFill>
+                <a:ea typeface="TH Sarabun New"/>
+                <a:cs typeface="TH Sarabun New"/>
+                <a:latin typeface="TH Sarabun New"/>
+              </a:rPr>
+              <a:t>ตรวจคะแนน</a:t>
+            </a:r>
+          </a:p>
+        </p:txBody>
+      </p:sp>
+      <p:sp>
+        <p:nvSpPr>
+          <p:cNvPr id="11" name="TextBox 10"/>
+          <p:cNvSpPr txBox="1"/>
+          <p:nvPr/>
+        </p:nvSpPr>
+        <p:spPr>
+          <a:xfrm>
+            <a:off x="8046720" y="5943600"/>
+            <a:ext cx="3840480" cy="365760"/>
+          </a:xfrm>
+          <a:prstGeom prst="rect">
+            <a:avLst/>
+          </a:prstGeom>
+          <a:noFill/>
+        </p:spPr>
+        <p:txBody>
+          <a:bodyPr wrap="square">
+            <a:spAutoFit/>
+          </a:bodyPr>
+          <a:lstStyle/>
+          <a:p>
+            <a:pPr algn="ctr"/>
+            <a:r>
+              <a:rPr sz="1300" b="0">
+                <a:solidFill>
+                  <a:srgbClr val="5B6775"/>
+                </a:solidFill>
+                <a:ea typeface="TH Sarabun New"/>
+                <a:cs typeface="TH Sarabun New"/>
+                <a:latin typeface="TH Sarabun New"/>
+              </a:rPr>
+              <a:t>ส่งออก</a:t>
+            </a:r>
+          </a:p>
+        </p:txBody>
+      </p:sp>
+    </p:spTree>
+  </p:cSld>
+  <p:clrMapOvr>
+    <a:masterClrMapping/>
+  </p:clrMapOvr>
+</p:sld>
+</file>
+
+<file path=ppt/slides/slide15.xml><?xml version="1.0" encoding="utf-8"?>
+<p:sld xmlns:a="http://schemas.openxmlformats.org/drawingml/2006/main" xmlns:p="http://schemas.openxmlformats.org/presentationml/2006/main" xmlns:r="http://schemas.openxmlformats.org/officeDocument/2006/relationships">
+  <p:cSld>
+    <p:spTree>
+      <p:nvGrpSpPr>
+        <p:cNvPr id="1" name=""/>
+        <p:cNvGrpSpPr/>
+        <p:nvPr/>
+      </p:nvGrpSpPr>
+      <p:grpSpPr/>
+      <p:sp>
+        <p:nvSpPr>
+          <p:cNvPr id="2" name="Rectangle 1"/>
+          <p:cNvSpPr/>
+          <p:nvPr/>
+        </p:nvSpPr>
+        <p:spPr>
+          <a:xfrm>
+            <a:off x="0" y="0"/>
+            <a:ext cx="12191695" cy="6858000"/>
+          </a:xfrm>
+          <a:prstGeom prst="rect">
+            <a:avLst/>
+          </a:prstGeom>
+          <a:solidFill>
+            <a:srgbClr val="FFFFFF"/>
+          </a:solidFill>
+          <a:ln>
+            <a:noFill/>
+          </a:ln>
+        </p:spPr>
+        <p:style>
+          <a:lnRef idx="1">
+            <a:schemeClr val="accent1"/>
+          </a:lnRef>
+          <a:fillRef idx="3">
+            <a:schemeClr val="accent1"/>
+          </a:fillRef>
+          <a:effectRef idx="2">
+            <a:schemeClr val="accent1"/>
+          </a:effectRef>
+          <a:fontRef idx="minor">
+            <a:schemeClr val="lt1"/>
+          </a:fontRef>
+        </p:style>
+        <p:txBody>
+          <a:bodyPr rtlCol="0" anchor="ctr"/>
+          <a:lstStyle/>
+          <a:p>
+            <a:pPr algn="ctr"/>
+          </a:p>
+        </p:txBody>
+      </p:sp>
+      <p:sp>
+        <p:nvSpPr>
+          <p:cNvPr id="3" name="Rectangle 2"/>
+          <p:cNvSpPr/>
+          <p:nvPr/>
+        </p:nvSpPr>
+        <p:spPr>
+          <a:xfrm>
+            <a:off x="0" y="0"/>
+            <a:ext cx="12191695" cy="109728"/>
+          </a:xfrm>
+          <a:prstGeom prst="rect">
+            <a:avLst/>
+          </a:prstGeom>
+          <a:solidFill>
+            <a:srgbClr val="F2A30A"/>
+          </a:solidFill>
+          <a:ln>
+            <a:noFill/>
+          </a:ln>
+        </p:spPr>
+        <p:style>
+          <a:lnRef idx="1">
+            <a:schemeClr val="accent1"/>
+          </a:lnRef>
+          <a:fillRef idx="3">
+            <a:schemeClr val="accent1"/>
+          </a:fillRef>
+          <a:effectRef idx="2">
+            <a:schemeClr val="accent1"/>
+          </a:effectRef>
+          <a:fontRef idx="minor">
+            <a:schemeClr val="lt1"/>
+          </a:fontRef>
+        </p:style>
+        <p:txBody>
+          <a:bodyPr rtlCol="0" anchor="ctr"/>
+          <a:lstStyle/>
+          <a:p>
+            <a:pPr algn="ctr"/>
+          </a:p>
+        </p:txBody>
+      </p:sp>
+      <p:sp>
+        <p:nvSpPr>
+          <p:cNvPr id="4" name="Rectangle 3"/>
+          <p:cNvSpPr/>
+          <p:nvPr/>
+        </p:nvSpPr>
+        <p:spPr>
+          <a:xfrm>
+            <a:off x="0" y="6583680"/>
+            <a:ext cx="12191695" cy="274320"/>
+          </a:xfrm>
+          <a:prstGeom prst="rect">
+            <a:avLst/>
+          </a:prstGeom>
+          <a:solidFill>
+            <a:srgbClr val="0F233E"/>
+          </a:solidFill>
+          <a:ln>
+            <a:noFill/>
+          </a:ln>
+        </p:spPr>
+        <p:style>
+          <a:lnRef idx="1">
+            <a:schemeClr val="accent1"/>
+          </a:lnRef>
+          <a:fillRef idx="3">
+            <a:schemeClr val="accent1"/>
+          </a:fillRef>
+          <a:effectRef idx="2">
+            <a:schemeClr val="accent1"/>
+          </a:effectRef>
+          <a:fontRef idx="minor">
+            <a:schemeClr val="lt1"/>
+          </a:fontRef>
+        </p:style>
+        <p:txBody>
+          <a:bodyPr rtlCol="0" anchor="ctr" wrap="none"/>
+          <a:lstStyle/>
+          <a:p>
+            <a:pPr algn="r"/>
+            <a:r>
+              <a:rPr sz="1200" b="0">
+                <a:solidFill>
+                  <a:srgbClr val="FFFFFF"/>
+                </a:solidFill>
+                <a:ea typeface="TH Sarabun New"/>
+                <a:cs typeface="TH Sarabun New"/>
+                <a:latin typeface="TH Sarabun New"/>
+              </a:rPr>
+              <a:t>TOR Generator  v0.2.3   ·   รายงานการทำงาน   ·   20 ส.ค. 2026</a:t>
+            </a:r>
+          </a:p>
+        </p:txBody>
+      </p:sp>
+      <p:sp>
+        <p:nvSpPr>
+          <p:cNvPr id="5" name="TextBox 4"/>
+          <p:cNvSpPr txBox="1"/>
+          <p:nvPr/>
+        </p:nvSpPr>
+        <p:spPr>
+          <a:xfrm>
+            <a:off x="457200" y="256032"/>
+            <a:ext cx="11247120" cy="457200"/>
+          </a:xfrm>
+          <a:prstGeom prst="rect">
+            <a:avLst/>
+          </a:prstGeom>
+          <a:noFill/>
+        </p:spPr>
+        <p:txBody>
+          <a:bodyPr wrap="square">
+            <a:spAutoFit/>
+          </a:bodyPr>
+          <a:lstStyle/>
+          <a:p>
+            <a:pPr algn="l"/>
+            <a:r>
+              <a:rPr sz="2600" b="1">
+                <a:solidFill>
+                  <a:srgbClr val="1D408C"/>
+                </a:solidFill>
+                <a:ea typeface="TH Sarabun New"/>
+                <a:cs typeface="TH Sarabun New"/>
+                <a:latin typeface="TH Sarabun New"/>
+              </a:rPr>
               <a:t>LangGraph และเส้นขนานเอเจนต์</a:t>
             </a:r>
           </a:p>
@@ -5276,7 +6115,7 @@
 </p:sld>
 </file>
 
-<file path=ppt/slides/slide15.xml><?xml version="1.0" encoding="utf-8"?>
+<file path=ppt/slides/slide16.xml><?xml version="1.0" encoding="utf-8"?>
 <p:sld xmlns:a="http://schemas.openxmlformats.org/drawingml/2006/main" xmlns:p="http://schemas.openxmlformats.org/presentationml/2006/main" xmlns:r="http://schemas.openxmlformats.org/officeDocument/2006/relationships">
   <p:cSld>
     <p:spTree>
@@ -5861,7 +6700,7 @@
 </p:sld>
 </file>
 
-<file path=ppt/slides/slide16.xml><?xml version="1.0" encoding="utf-8"?>
+<file path=ppt/slides/slide17.xml><?xml version="1.0" encoding="utf-8"?>
 <p:sld xmlns:a="http://schemas.openxmlformats.org/drawingml/2006/main" xmlns:p="http://schemas.openxmlformats.org/presentationml/2006/main" xmlns:r="http://schemas.openxmlformats.org/officeDocument/2006/relationships">
   <p:cSld>
     <p:spTree>
@@ -6582,7 +7421,7 @@
 </p:sld>
 </file>
 
-<file path=ppt/slides/slide17.xml><?xml version="1.0" encoding="utf-8"?>
+<file path=ppt/slides/slide18.xml><?xml version="1.0" encoding="utf-8"?>
 <p:sld xmlns:a="http://schemas.openxmlformats.org/drawingml/2006/main" xmlns:p="http://schemas.openxmlformats.org/presentationml/2006/main" xmlns:r="http://schemas.openxmlformats.org/officeDocument/2006/relationships">
   <p:cSld>
     <p:spTree>
@@ -7115,7 +7954,7 @@
 </p:sld>
 </file>
 
-<file path=ppt/slides/slide18.xml><?xml version="1.0" encoding="utf-8"?>
+<file path=ppt/slides/slide19.xml><?xml version="1.0" encoding="utf-8"?>
 <p:sld xmlns:a="http://schemas.openxmlformats.org/drawingml/2006/main" xmlns:p="http://schemas.openxmlformats.org/presentationml/2006/main" xmlns:r="http://schemas.openxmlformats.org/officeDocument/2006/relationships">
   <p:cSld>
     <p:spTree>
@@ -7752,249 +8591,6 @@
 </p:sld>
 </file>
 
-<file path=ppt/slides/slide19.xml><?xml version="1.0" encoding="utf-8"?>
-<p:sld xmlns:a="http://schemas.openxmlformats.org/drawingml/2006/main" xmlns:p="http://schemas.openxmlformats.org/presentationml/2006/main" xmlns:r="http://schemas.openxmlformats.org/officeDocument/2006/relationships">
-  <p:cSld>
-    <p:spTree>
-      <p:nvGrpSpPr>
-        <p:cNvPr id="1" name=""/>
-        <p:cNvGrpSpPr/>
-        <p:nvPr/>
-      </p:nvGrpSpPr>
-      <p:grpSpPr/>
-      <p:sp>
-        <p:nvSpPr>
-          <p:cNvPr id="2" name="Rectangle 1"/>
-          <p:cNvSpPr/>
-          <p:nvPr/>
-        </p:nvSpPr>
-        <p:spPr>
-          <a:xfrm>
-            <a:off x="0" y="0"/>
-            <a:ext cx="12191695" cy="6858000"/>
-          </a:xfrm>
-          <a:prstGeom prst="rect">
-            <a:avLst/>
-          </a:prstGeom>
-          <a:solidFill>
-            <a:srgbClr val="FFFFFF"/>
-          </a:solidFill>
-          <a:ln>
-            <a:noFill/>
-          </a:ln>
-        </p:spPr>
-        <p:style>
-          <a:lnRef idx="1">
-            <a:schemeClr val="accent1"/>
-          </a:lnRef>
-          <a:fillRef idx="3">
-            <a:schemeClr val="accent1"/>
-          </a:fillRef>
-          <a:effectRef idx="2">
-            <a:schemeClr val="accent1"/>
-          </a:effectRef>
-          <a:fontRef idx="minor">
-            <a:schemeClr val="lt1"/>
-          </a:fontRef>
-        </p:style>
-        <p:txBody>
-          <a:bodyPr rtlCol="0" anchor="ctr"/>
-          <a:lstStyle/>
-          <a:p>
-            <a:pPr algn="ctr"/>
-          </a:p>
-        </p:txBody>
-      </p:sp>
-      <p:sp>
-        <p:nvSpPr>
-          <p:cNvPr id="3" name="Rectangle 2"/>
-          <p:cNvSpPr/>
-          <p:nvPr/>
-        </p:nvSpPr>
-        <p:spPr>
-          <a:xfrm>
-            <a:off x="0" y="0"/>
-            <a:ext cx="12191695" cy="109728"/>
-          </a:xfrm>
-          <a:prstGeom prst="rect">
-            <a:avLst/>
-          </a:prstGeom>
-          <a:solidFill>
-            <a:srgbClr val="F2A30A"/>
-          </a:solidFill>
-          <a:ln>
-            <a:noFill/>
-          </a:ln>
-        </p:spPr>
-        <p:style>
-          <a:lnRef idx="1">
-            <a:schemeClr val="accent1"/>
-          </a:lnRef>
-          <a:fillRef idx="3">
-            <a:schemeClr val="accent1"/>
-          </a:fillRef>
-          <a:effectRef idx="2">
-            <a:schemeClr val="accent1"/>
-          </a:effectRef>
-          <a:fontRef idx="minor">
-            <a:schemeClr val="lt1"/>
-          </a:fontRef>
-        </p:style>
-        <p:txBody>
-          <a:bodyPr rtlCol="0" anchor="ctr"/>
-          <a:lstStyle/>
-          <a:p>
-            <a:pPr algn="ctr"/>
-          </a:p>
-        </p:txBody>
-      </p:sp>
-      <p:sp>
-        <p:nvSpPr>
-          <p:cNvPr id="4" name="Rectangle 3"/>
-          <p:cNvSpPr/>
-          <p:nvPr/>
-        </p:nvSpPr>
-        <p:spPr>
-          <a:xfrm>
-            <a:off x="0" y="6583680"/>
-            <a:ext cx="12191695" cy="274320"/>
-          </a:xfrm>
-          <a:prstGeom prst="rect">
-            <a:avLst/>
-          </a:prstGeom>
-          <a:solidFill>
-            <a:srgbClr val="0F233E"/>
-          </a:solidFill>
-          <a:ln>
-            <a:noFill/>
-          </a:ln>
-        </p:spPr>
-        <p:style>
-          <a:lnRef idx="1">
-            <a:schemeClr val="accent1"/>
-          </a:lnRef>
-          <a:fillRef idx="3">
-            <a:schemeClr val="accent1"/>
-          </a:fillRef>
-          <a:effectRef idx="2">
-            <a:schemeClr val="accent1"/>
-          </a:effectRef>
-          <a:fontRef idx="minor">
-            <a:schemeClr val="lt1"/>
-          </a:fontRef>
-        </p:style>
-        <p:txBody>
-          <a:bodyPr rtlCol="0" anchor="ctr" wrap="none"/>
-          <a:lstStyle/>
-          <a:p>
-            <a:pPr algn="r"/>
-            <a:r>
-              <a:rPr sz="1200" b="0">
-                <a:solidFill>
-                  <a:srgbClr val="FFFFFF"/>
-                </a:solidFill>
-                <a:ea typeface="TH Sarabun New"/>
-                <a:cs typeface="TH Sarabun New"/>
-                <a:latin typeface="TH Sarabun New"/>
-              </a:rPr>
-              <a:t>TOR Generator  v0.2.3   ·   รายงานการทำงาน   ·   20 ส.ค. 2026</a:t>
-            </a:r>
-          </a:p>
-        </p:txBody>
-      </p:sp>
-      <p:sp>
-        <p:nvSpPr>
-          <p:cNvPr id="5" name="TextBox 4"/>
-          <p:cNvSpPr txBox="1"/>
-          <p:nvPr/>
-        </p:nvSpPr>
-        <p:spPr>
-          <a:xfrm>
-            <a:off x="457200" y="256032"/>
-            <a:ext cx="11247120" cy="457200"/>
-          </a:xfrm>
-          <a:prstGeom prst="rect">
-            <a:avLst/>
-          </a:prstGeom>
-          <a:noFill/>
-        </p:spPr>
-        <p:txBody>
-          <a:bodyPr wrap="square">
-            <a:spAutoFit/>
-          </a:bodyPr>
-          <a:lstStyle/>
-          <a:p>
-            <a:pPr algn="l"/>
-            <a:r>
-              <a:rPr sz="2600" b="1">
-                <a:solidFill>
-                  <a:srgbClr val="1D408C"/>
-                </a:solidFill>
-                <a:ea typeface="TH Sarabun New"/>
-                <a:cs typeface="TH Sarabun New"/>
-                <a:latin typeface="TH Sarabun New"/>
-              </a:rPr>
-              <a:t>Unit tests ที่รันจริง — 20 ส.ค. 2026</a:t>
-            </a:r>
-          </a:p>
-        </p:txBody>
-      </p:sp>
-      <p:pic>
-        <p:nvPicPr>
-          <p:cNvPr id="6" name="Picture 5" descr="19-vitest-output.png"/>
-          <p:cNvPicPr>
-            <a:picLocks noChangeAspect="1"/>
-          </p:cNvPicPr>
-          <p:nvPr/>
-        </p:nvPicPr>
-        <p:blipFill>
-          <a:blip r:embed="rId2"/>
-          <a:stretch>
-            <a:fillRect/>
-          </a:stretch>
-        </p:blipFill>
-        <p:spPr>
-          <a:xfrm>
-            <a:off x="320040" y="868680"/>
-            <a:ext cx="5669280" cy="3643037"/>
-          </a:xfrm>
-          <a:prstGeom prst="rect">
-            <a:avLst/>
-          </a:prstGeom>
-        </p:spPr>
-      </p:pic>
-      <p:pic>
-        <p:nvPicPr>
-          <p:cNvPr id="7" name="Picture 6" descr="19-pytest-output.png"/>
-          <p:cNvPicPr>
-            <a:picLocks noChangeAspect="1"/>
-          </p:cNvPicPr>
-          <p:nvPr/>
-        </p:nvPicPr>
-        <p:blipFill>
-          <a:blip r:embed="rId3"/>
-          <a:stretch>
-            <a:fillRect/>
-          </a:stretch>
-        </p:blipFill>
-        <p:spPr>
-          <a:xfrm>
-            <a:off x="6172200" y="868680"/>
-            <a:ext cx="5669280" cy="2615826"/>
-          </a:xfrm>
-          <a:prstGeom prst="rect">
-            <a:avLst/>
-          </a:prstGeom>
-        </p:spPr>
-      </p:pic>
-    </p:spTree>
-  </p:cSld>
-  <p:clrMapOvr>
-    <a:masterClrMapping/>
-  </p:clrMapOvr>
-</p:sld>
-</file>
-
 <file path=ppt/slides/slide2.xml><?xml version="1.0" encoding="utf-8"?>
 <p:sld xmlns:a="http://schemas.openxmlformats.org/drawingml/2006/main" xmlns:p="http://schemas.openxmlformats.org/presentationml/2006/main" xmlns:r="http://schemas.openxmlformats.org/officeDocument/2006/relationships">
   <p:cSld>
@@ -8557,7 +9153,7 @@
                           <a:cs typeface="TH Sarabun New"/>
                           <a:latin typeface="TH Sarabun New"/>
                         </a:rPr>
-                        <a:t>Unit tests จริง 20 ส.ค. 2026 (Vitest 122 / pytest 1448)</a:t>
+                        <a:t>Unit tests จริง 20 ส.ค. 2026 (Vitest 128 / pytest 1448 + live 10 / E2E headed 15)</a:t>
                       </a:r>
                     </a:p>
                   </a:txBody>
@@ -8762,14 +9358,14 @@
                 <a:cs typeface="TH Sarabun New"/>
                 <a:latin typeface="TH Sarabun New"/>
               </a:rPr>
-              <a:t>เทสต์ล็อกการใช้งานอย่างไร</a:t>
+              <a:t>Unit tests ที่รันจริง — 20 ส.ค. 2026</a:t>
             </a:r>
           </a:p>
         </p:txBody>
       </p:sp>
       <p:pic>
         <p:nvPicPr>
-          <p:cNvPr id="6" name="Picture 5" descr="19-unit-test-usage-map.png"/>
+          <p:cNvPr id="6" name="Picture 5" descr="19-vitest-output.png"/>
           <p:cNvPicPr>
             <a:picLocks noChangeAspect="1"/>
           </p:cNvPicPr>
@@ -8783,8 +9379,32 @@
         </p:blipFill>
         <p:spPr>
           <a:xfrm>
-            <a:off x="502920" y="822960"/>
-            <a:ext cx="11155680" cy="8018145"/>
+            <a:off x="320040" y="868680"/>
+            <a:ext cx="5669280" cy="3643037"/>
+          </a:xfrm>
+          <a:prstGeom prst="rect">
+            <a:avLst/>
+          </a:prstGeom>
+        </p:spPr>
+      </p:pic>
+      <p:pic>
+        <p:nvPicPr>
+          <p:cNvPr id="7" name="Picture 6" descr="19-pytest-output.png"/>
+          <p:cNvPicPr>
+            <a:picLocks noChangeAspect="1"/>
+          </p:cNvPicPr>
+          <p:nvPr/>
+        </p:nvPicPr>
+        <p:blipFill>
+          <a:blip r:embed="rId3"/>
+          <a:stretch>
+            <a:fillRect/>
+          </a:stretch>
+        </p:blipFill>
+        <p:spPr>
+          <a:xfrm>
+            <a:off x="6172200" y="868680"/>
+            <a:ext cx="5669280" cy="2615826"/>
           </a:xfrm>
           <a:prstGeom prst="rect">
             <a:avLst/>
@@ -8981,142 +9601,35 @@
                 <a:cs typeface="TH Sarabun New"/>
                 <a:latin typeface="TH Sarabun New"/>
               </a:rPr>
-              <a:t>วิธีรันเทสต์เอง</a:t>
-            </a:r>
-          </a:p>
-        </p:txBody>
-      </p:sp>
-      <p:sp>
-        <p:nvSpPr>
-          <p:cNvPr id="6" name="TextBox 5"/>
-          <p:cNvSpPr txBox="1"/>
+              <a:t>เทสต์ล็อกการใช้งานอย่างไร</a:t>
+            </a:r>
+          </a:p>
+        </p:txBody>
+      </p:sp>
+      <p:pic>
+        <p:nvPicPr>
+          <p:cNvPr id="6" name="Picture 5" descr="19-unit-test-usage-map.png"/>
+          <p:cNvPicPr>
+            <a:picLocks noChangeAspect="1"/>
+          </p:cNvPicPr>
           <p:nvPr/>
-        </p:nvSpPr>
-        <p:spPr>
-          <a:xfrm>
-            <a:off x="502920" y="868680"/>
-            <a:ext cx="11155680" cy="5394960"/>
+        </p:nvPicPr>
+        <p:blipFill>
+          <a:blip r:embed="rId2"/>
+          <a:stretch>
+            <a:fillRect/>
+          </a:stretch>
+        </p:blipFill>
+        <p:spPr>
+          <a:xfrm>
+            <a:off x="502920" y="822960"/>
+            <a:ext cx="11155680" cy="8018145"/>
           </a:xfrm>
           <a:prstGeom prst="rect">
             <a:avLst/>
           </a:prstGeom>
-          <a:noFill/>
-        </p:spPr>
-        <p:txBody>
-          <a:bodyPr wrap="square">
-            <a:spAutoFit/>
-          </a:bodyPr>
-          <a:lstStyle/>
-          <a:p>
-            <a:pPr>
-              <a:spcAft>
-                <a:spcPts val="800"/>
-              </a:spcAft>
-            </a:pPr>
-            <a:r>
-              <a:rPr sz="1700" b="0">
-                <a:solidFill>
-                  <a:srgbClr val="1F2A37"/>
-                </a:solidFill>
-                <a:ea typeface="TH Sarabun New"/>
-                <a:cs typeface="TH Sarabun New"/>
-                <a:latin typeface="TH Sarabun New"/>
-              </a:rPr>
-              <a:t>•  Frontend:  cd app/frontend &amp;&amp; npm run test:unit</a:t>
-            </a:r>
-          </a:p>
-          <a:p>
-            <a:pPr>
-              <a:spcAft>
-                <a:spcPts val="800"/>
-              </a:spcAft>
-            </a:pPr>
-            <a:r>
-              <a:rPr sz="1700" b="0">
-                <a:solidFill>
-                  <a:srgbClr val="1F2A37"/>
-                </a:solidFill>
-                <a:ea typeface="TH Sarabun New"/>
-                <a:cs typeface="TH Sarabun New"/>
-                <a:latin typeface="TH Sarabun New"/>
-              </a:rPr>
-              <a:t>•  Backend:   cd app/backend &amp;&amp; python -m pytest -m "not live_llm" --hypothesis-profile=coverage</a:t>
-            </a:r>
-          </a:p>
-          <a:p>
-            <a:pPr>
-              <a:spcAft>
-                <a:spcPts val="800"/>
-              </a:spcAft>
-            </a:pPr>
-            <a:r>
-              <a:rPr sz="1700" b="0">
-                <a:solidFill>
-                  <a:srgbClr val="1F2A37"/>
-                </a:solidFill>
-                <a:ea typeface="TH Sarabun New"/>
-                <a:cs typeface="TH Sarabun New"/>
-                <a:latin typeface="TH Sarabun New"/>
-              </a:rPr>
-              <a:t>•  ถ้า LM Studio เปิดที่ :1234:  python -m pytest -m live_llm</a:t>
-            </a:r>
-          </a:p>
-          <a:p>
-            <a:pPr>
-              <a:spcAft>
-                <a:spcPts val="800"/>
-              </a:spcAft>
-            </a:pPr>
-            <a:r>
-              <a:rPr sz="1700" b="0">
-                <a:solidFill>
-                  <a:srgbClr val="1F2A37"/>
-                </a:solidFill>
-                <a:ea typeface="TH Sarabun New"/>
-                <a:cs typeface="TH Sarabun New"/>
-                <a:latin typeface="TH Sarabun New"/>
-              </a:rPr>
-              <a:t>•  E2E (ต้องมี UI ที่ :3000):  npm run test:e2e:headed</a:t>
-            </a:r>
-          </a:p>
-          <a:p>
-            <a:pPr>
-              <a:spcAft>
-                <a:spcPts val="800"/>
-              </a:spcAft>
-            </a:pPr>
-            <a:r>
-              <a:rPr sz="1700" b="0">
-                <a:solidFill>
-                  <a:srgbClr val="1F2A37"/>
-                </a:solidFill>
-                <a:ea typeface="TH Sarabun New"/>
-                <a:cs typeface="TH Sarabun New"/>
-                <a:latin typeface="TH Sarabun New"/>
-              </a:rPr>
-              <a:t>•  บัญชีทดลอง: officer@example.go.th / Passw0rd!</a:t>
-            </a:r>
-          </a:p>
-          <a:p>
-            <a:pPr>
-              <a:spcAft>
-                <a:spcPts val="800"/>
-              </a:spcAft>
-            </a:pPr>
-            <a:r>
-              <a:rPr sz="1700" b="0">
-                <a:solidFill>
-                  <a:srgbClr val="1F2A37"/>
-                </a:solidFill>
-                <a:ea typeface="TH Sarabun New"/>
-                <a:cs typeface="TH Sarabun New"/>
-                <a:latin typeface="TH Sarabun New"/>
-              </a:rPr>
-              <a:t>•  รอบนี้ไม่ได้รัน 10 เคส live_llm เพราะไม่ได้เปิด LM Studio — ไม่ใช่เคสที่ล้ม</a:t>
-            </a:r>
-          </a:p>
-        </p:txBody>
-      </p:sp>
+        </p:spPr>
+      </p:pic>
     </p:spTree>
   </p:cSld>
   <p:clrMapOvr>
@@ -9307,7 +9820,7 @@
                 <a:cs typeface="TH Sarabun New"/>
                 <a:latin typeface="TH Sarabun New"/>
               </a:rPr>
-              <a:t>ขอบเขตที่ยังไม่ครบในสภาพแวดล้อมนี้</a:t>
+              <a:t>วิธีรันเทสต์เอง</a:t>
             </a:r>
           </a:p>
         </p:txBody>
@@ -9340,7 +9853,7 @@
               </a:spcAft>
             </a:pPr>
             <a:r>
-              <a:rPr sz="1600" b="0">
+              <a:rPr sz="1700" b="0">
                 <a:solidFill>
                   <a:srgbClr val="1F2A37"/>
                 </a:solidFill>
@@ -9348,7 +9861,7 @@
                 <a:cs typeface="TH Sarabun New"/>
                 <a:latin typeface="TH Sarabun New"/>
               </a:rPr>
-              <a:t>•  ไม่มี LLM ในเครื่อง → Phase 2 / แชทผิดพลาด แต่กรอกมือและส่งออกได้</a:t>
+              <a:t>•  Frontend:  cd app/frontend &amp;&amp; npm run test:unit</a:t>
             </a:r>
           </a:p>
           <a:p>
@@ -9358,7 +9871,7 @@
               </a:spcAft>
             </a:pPr>
             <a:r>
-              <a:rPr sz="1600" b="0">
+              <a:rPr sz="1700" b="0">
                 <a:solidFill>
                   <a:srgbClr val="1F2A37"/>
                 </a:solidFill>
@@ -9366,7 +9879,7 @@
                 <a:cs typeface="TH Sarabun New"/>
                 <a:latin typeface="TH Sarabun New"/>
               </a:rPr>
-              <a:t>•  Neo4j ไม่ขึ้น → แชทยังตอบจาก pgvector แต่ไม่มีกราฟกฎหมาย</a:t>
+              <a:t>•  Backend:   cd app/backend &amp;&amp; python -m pytest -m "not live_llm" --hypothesis-profile=coverage</a:t>
             </a:r>
           </a:p>
           <a:p>
@@ -9376,7 +9889,7 @@
               </a:spcAft>
             </a:pPr>
             <a:r>
-              <a:rPr sz="1600" b="0">
+              <a:rPr sz="1700" b="0">
                 <a:solidFill>
                   <a:srgbClr val="1F2A37"/>
                 </a:solidFill>
@@ -9384,7 +9897,7 @@
                 <a:cs typeface="TH Sarabun New"/>
                 <a:latin typeface="TH Sarabun New"/>
               </a:rPr>
-              <a:t>•  ไม่มี e-GP จริง และไม่มี LangGraph checkpointer</a:t>
+              <a:t>•  ถ้า LM Studio เปิดที่ :1234:  python -m pytest -m live_llm</a:t>
             </a:r>
           </a:p>
           <a:p>
@@ -9394,7 +9907,7 @@
               </a:spcAft>
             </a:pPr>
             <a:r>
-              <a:rPr sz="1600" b="0">
+              <a:rPr sz="1700" b="0">
                 <a:solidFill>
                   <a:srgbClr val="1F2A37"/>
                 </a:solidFill>
@@ -9402,7 +9915,7 @@
                 <a:cs typeface="TH Sarabun New"/>
                 <a:latin typeface="TH Sarabun New"/>
               </a:rPr>
-              <a:t>•  /api/v1/agent และ /api/v1/kb-chat ยังไม่มีหน้า Next.js</a:t>
+              <a:t>•  E2E headed (ต้องมี UI ที่ :3000):  npm run test:e2e:headed</a:t>
             </a:r>
           </a:p>
           <a:p>
@@ -9412,7 +9925,7 @@
               </a:spcAft>
             </a:pPr>
             <a:r>
-              <a:rPr sz="1600" b="0">
+              <a:rPr sz="1700" b="0">
                 <a:solidFill>
                   <a:srgbClr val="1F2A37"/>
                 </a:solidFill>
@@ -9420,7 +9933,43 @@
                 <a:cs typeface="TH Sarabun New"/>
                 <a:latin typeface="TH Sarabun New"/>
               </a:rPr>
-              <a:t>•  อย่าใช้เอกสารออกแบบ 10 / 11 เป็นคู่มือติดตั้งของสแตก Docker ปัจจุบัน</a:t>
+              <a:t>•  Guide screenshots:  npm run test:e2e:guide</a:t>
+            </a:r>
+          </a:p>
+          <a:p>
+            <a:pPr>
+              <a:spcAft>
+                <a:spcPts val="800"/>
+              </a:spcAft>
+            </a:pPr>
+            <a:r>
+              <a:rPr sz="1700" b="0">
+                <a:solidFill>
+                  <a:srgbClr val="1F2A37"/>
+                </a:solidFill>
+                <a:ea typeface="TH Sarabun New"/>
+                <a:cs typeface="TH Sarabun New"/>
+                <a:latin typeface="TH Sarabun New"/>
+              </a:rPr>
+              <a:t>•  บัญชีทดลอง: officer@example.go.th / Passw0rd!</a:t>
+            </a:r>
+          </a:p>
+          <a:p>
+            <a:pPr>
+              <a:spcAft>
+                <a:spcPts val="800"/>
+              </a:spcAft>
+            </a:pPr>
+            <a:r>
+              <a:rPr sz="1700" b="0">
+                <a:solidFill>
+                  <a:srgbClr val="1F2A37"/>
+                </a:solidFill>
+                <a:ea typeface="TH Sarabun New"/>
+                <a:cs typeface="TH Sarabun New"/>
+                <a:latin typeface="TH Sarabun New"/>
+              </a:rPr>
+              <a:t>•  live_llm 10 เคสผ่านเมื่อเปิด LM Studio ที่ :1234 — รวม backend 1458 เคส</a:t>
             </a:r>
           </a:p>
         </p:txBody>
@@ -9615,6 +10164,314 @@
                 <a:cs typeface="TH Sarabun New"/>
                 <a:latin typeface="TH Sarabun New"/>
               </a:rPr>
+              <a:t>ขอบเขตที่ยังไม่ครบในสภาพแวดล้อมนี้</a:t>
+            </a:r>
+          </a:p>
+        </p:txBody>
+      </p:sp>
+      <p:sp>
+        <p:nvSpPr>
+          <p:cNvPr id="6" name="TextBox 5"/>
+          <p:cNvSpPr txBox="1"/>
+          <p:nvPr/>
+        </p:nvSpPr>
+        <p:spPr>
+          <a:xfrm>
+            <a:off x="502920" y="868680"/>
+            <a:ext cx="11155680" cy="5394960"/>
+          </a:xfrm>
+          <a:prstGeom prst="rect">
+            <a:avLst/>
+          </a:prstGeom>
+          <a:noFill/>
+        </p:spPr>
+        <p:txBody>
+          <a:bodyPr wrap="square">
+            <a:spAutoFit/>
+          </a:bodyPr>
+          <a:lstStyle/>
+          <a:p>
+            <a:pPr>
+              <a:spcAft>
+                <a:spcPts val="800"/>
+              </a:spcAft>
+            </a:pPr>
+            <a:r>
+              <a:rPr sz="1600" b="0">
+                <a:solidFill>
+                  <a:srgbClr val="1F2A37"/>
+                </a:solidFill>
+                <a:ea typeface="TH Sarabun New"/>
+                <a:cs typeface="TH Sarabun New"/>
+                <a:latin typeface="TH Sarabun New"/>
+              </a:rPr>
+              <a:t>•  ไม่มี LLM ในเครื่อง → Phase 2 / แชทผิดพลาด แต่กรอกมือและส่งออกได้</a:t>
+            </a:r>
+          </a:p>
+          <a:p>
+            <a:pPr>
+              <a:spcAft>
+                <a:spcPts val="800"/>
+              </a:spcAft>
+            </a:pPr>
+            <a:r>
+              <a:rPr sz="1600" b="0">
+                <a:solidFill>
+                  <a:srgbClr val="1F2A37"/>
+                </a:solidFill>
+                <a:ea typeface="TH Sarabun New"/>
+                <a:cs typeface="TH Sarabun New"/>
+                <a:latin typeface="TH Sarabun New"/>
+              </a:rPr>
+              <a:t>•  Neo4j ไม่ขึ้น → แชทยังตอบจาก pgvector แต่ไม่มีกราฟกฎหมาย</a:t>
+            </a:r>
+          </a:p>
+          <a:p>
+            <a:pPr>
+              <a:spcAft>
+                <a:spcPts val="800"/>
+              </a:spcAft>
+            </a:pPr>
+            <a:r>
+              <a:rPr sz="1600" b="0">
+                <a:solidFill>
+                  <a:srgbClr val="1F2A37"/>
+                </a:solidFill>
+                <a:ea typeface="TH Sarabun New"/>
+                <a:cs typeface="TH Sarabun New"/>
+                <a:latin typeface="TH Sarabun New"/>
+              </a:rPr>
+              <a:t>•  ไม่มี e-GP จริง และไม่มี LangGraph checkpointer</a:t>
+            </a:r>
+          </a:p>
+          <a:p>
+            <a:pPr>
+              <a:spcAft>
+                <a:spcPts val="800"/>
+              </a:spcAft>
+            </a:pPr>
+            <a:r>
+              <a:rPr sz="1600" b="0">
+                <a:solidFill>
+                  <a:srgbClr val="1F2A37"/>
+                </a:solidFill>
+                <a:ea typeface="TH Sarabun New"/>
+                <a:cs typeface="TH Sarabun New"/>
+                <a:latin typeface="TH Sarabun New"/>
+              </a:rPr>
+              <a:t>•  /api/v1/agent และ /api/v1/kb-chat ยังไม่มีหน้า Next.js</a:t>
+            </a:r>
+          </a:p>
+          <a:p>
+            <a:pPr>
+              <a:spcAft>
+                <a:spcPts val="800"/>
+              </a:spcAft>
+            </a:pPr>
+            <a:r>
+              <a:rPr sz="1600" b="0">
+                <a:solidFill>
+                  <a:srgbClr val="1F2A37"/>
+                </a:solidFill>
+                <a:ea typeface="TH Sarabun New"/>
+                <a:cs typeface="TH Sarabun New"/>
+                <a:latin typeface="TH Sarabun New"/>
+              </a:rPr>
+              <a:t>•  อย่าใช้เอกสารออกแบบ 10 / 11 เป็นคู่มือติดตั้งของสแตก Docker ปัจจุบัน</a:t>
+            </a:r>
+          </a:p>
+        </p:txBody>
+      </p:sp>
+    </p:spTree>
+  </p:cSld>
+  <p:clrMapOvr>
+    <a:masterClrMapping/>
+  </p:clrMapOvr>
+</p:sld>
+</file>
+
+<file path=ppt/slides/slide24.xml><?xml version="1.0" encoding="utf-8"?>
+<p:sld xmlns:a="http://schemas.openxmlformats.org/drawingml/2006/main" xmlns:p="http://schemas.openxmlformats.org/presentationml/2006/main" xmlns:r="http://schemas.openxmlformats.org/officeDocument/2006/relationships">
+  <p:cSld>
+    <p:spTree>
+      <p:nvGrpSpPr>
+        <p:cNvPr id="1" name=""/>
+        <p:cNvGrpSpPr/>
+        <p:nvPr/>
+      </p:nvGrpSpPr>
+      <p:grpSpPr/>
+      <p:sp>
+        <p:nvSpPr>
+          <p:cNvPr id="2" name="Rectangle 1"/>
+          <p:cNvSpPr/>
+          <p:nvPr/>
+        </p:nvSpPr>
+        <p:spPr>
+          <a:xfrm>
+            <a:off x="0" y="0"/>
+            <a:ext cx="12191695" cy="6858000"/>
+          </a:xfrm>
+          <a:prstGeom prst="rect">
+            <a:avLst/>
+          </a:prstGeom>
+          <a:solidFill>
+            <a:srgbClr val="FFFFFF"/>
+          </a:solidFill>
+          <a:ln>
+            <a:noFill/>
+          </a:ln>
+        </p:spPr>
+        <p:style>
+          <a:lnRef idx="1">
+            <a:schemeClr val="accent1"/>
+          </a:lnRef>
+          <a:fillRef idx="3">
+            <a:schemeClr val="accent1"/>
+          </a:fillRef>
+          <a:effectRef idx="2">
+            <a:schemeClr val="accent1"/>
+          </a:effectRef>
+          <a:fontRef idx="minor">
+            <a:schemeClr val="lt1"/>
+          </a:fontRef>
+        </p:style>
+        <p:txBody>
+          <a:bodyPr rtlCol="0" anchor="ctr"/>
+          <a:lstStyle/>
+          <a:p>
+            <a:pPr algn="ctr"/>
+          </a:p>
+        </p:txBody>
+      </p:sp>
+      <p:sp>
+        <p:nvSpPr>
+          <p:cNvPr id="3" name="Rectangle 2"/>
+          <p:cNvSpPr/>
+          <p:nvPr/>
+        </p:nvSpPr>
+        <p:spPr>
+          <a:xfrm>
+            <a:off x="0" y="0"/>
+            <a:ext cx="12191695" cy="109728"/>
+          </a:xfrm>
+          <a:prstGeom prst="rect">
+            <a:avLst/>
+          </a:prstGeom>
+          <a:solidFill>
+            <a:srgbClr val="F2A30A"/>
+          </a:solidFill>
+          <a:ln>
+            <a:noFill/>
+          </a:ln>
+        </p:spPr>
+        <p:style>
+          <a:lnRef idx="1">
+            <a:schemeClr val="accent1"/>
+          </a:lnRef>
+          <a:fillRef idx="3">
+            <a:schemeClr val="accent1"/>
+          </a:fillRef>
+          <a:effectRef idx="2">
+            <a:schemeClr val="accent1"/>
+          </a:effectRef>
+          <a:fontRef idx="minor">
+            <a:schemeClr val="lt1"/>
+          </a:fontRef>
+        </p:style>
+        <p:txBody>
+          <a:bodyPr rtlCol="0" anchor="ctr"/>
+          <a:lstStyle/>
+          <a:p>
+            <a:pPr algn="ctr"/>
+          </a:p>
+        </p:txBody>
+      </p:sp>
+      <p:sp>
+        <p:nvSpPr>
+          <p:cNvPr id="4" name="Rectangle 3"/>
+          <p:cNvSpPr/>
+          <p:nvPr/>
+        </p:nvSpPr>
+        <p:spPr>
+          <a:xfrm>
+            <a:off x="0" y="6583680"/>
+            <a:ext cx="12191695" cy="274320"/>
+          </a:xfrm>
+          <a:prstGeom prst="rect">
+            <a:avLst/>
+          </a:prstGeom>
+          <a:solidFill>
+            <a:srgbClr val="0F233E"/>
+          </a:solidFill>
+          <a:ln>
+            <a:noFill/>
+          </a:ln>
+        </p:spPr>
+        <p:style>
+          <a:lnRef idx="1">
+            <a:schemeClr val="accent1"/>
+          </a:lnRef>
+          <a:fillRef idx="3">
+            <a:schemeClr val="accent1"/>
+          </a:fillRef>
+          <a:effectRef idx="2">
+            <a:schemeClr val="accent1"/>
+          </a:effectRef>
+          <a:fontRef idx="minor">
+            <a:schemeClr val="lt1"/>
+          </a:fontRef>
+        </p:style>
+        <p:txBody>
+          <a:bodyPr rtlCol="0" anchor="ctr" wrap="none"/>
+          <a:lstStyle/>
+          <a:p>
+            <a:pPr algn="r"/>
+            <a:r>
+              <a:rPr sz="1200" b="0">
+                <a:solidFill>
+                  <a:srgbClr val="FFFFFF"/>
+                </a:solidFill>
+                <a:ea typeface="TH Sarabun New"/>
+                <a:cs typeface="TH Sarabun New"/>
+                <a:latin typeface="TH Sarabun New"/>
+              </a:rPr>
+              <a:t>TOR Generator  v0.2.3   ·   รายงานการทำงาน   ·   20 ส.ค. 2026</a:t>
+            </a:r>
+          </a:p>
+        </p:txBody>
+      </p:sp>
+      <p:sp>
+        <p:nvSpPr>
+          <p:cNvPr id="5" name="TextBox 4"/>
+          <p:cNvSpPr txBox="1"/>
+          <p:nvPr/>
+        </p:nvSpPr>
+        <p:spPr>
+          <a:xfrm>
+            <a:off x="457200" y="256032"/>
+            <a:ext cx="11247120" cy="457200"/>
+          </a:xfrm>
+          <a:prstGeom prst="rect">
+            <a:avLst/>
+          </a:prstGeom>
+          <a:noFill/>
+        </p:spPr>
+        <p:txBody>
+          <a:bodyPr wrap="square">
+            <a:spAutoFit/>
+          </a:bodyPr>
+          <a:lstStyle/>
+          <a:p>
+            <a:pPr algn="l"/>
+            <a:r>
+              <a:rPr sz="2600" b="1">
+                <a:solidFill>
+                  <a:srgbClr val="1D408C"/>
+                </a:solidFill>
+                <a:ea typeface="TH Sarabun New"/>
+                <a:cs typeface="TH Sarabun New"/>
+                <a:latin typeface="TH Sarabun New"/>
+              </a:rPr>
               <a:t>สรุป</a:t>
             </a:r>
           </a:p>
@@ -9710,7 +10567,7 @@
                 <a:cs typeface="TH Sarabun New"/>
                 <a:latin typeface="TH Sarabun New"/>
               </a:rPr>
-              <a:t>•  Unit tests ล็อกพฤติกรรมนี้ไว้แล้ว: Vitest 122 ผ่าน, pytest 1448 ผ่าน</a:t>
+              <a:t>•  Unit tests ล็อกพฤติกรรมนี้ไว้แล้ว: Vitest 128, pytest 1448 + live_llm 10, Playwright headed 15</a:t>
             </a:r>
           </a:p>
           <a:p>
@@ -11065,7 +11922,7 @@
         <p:spPr>
           <a:xfrm>
             <a:off x="6126480" y="914400"/>
-            <a:ext cx="5577840" cy="6770878"/>
+            <a:ext cx="5577840" cy="3486150"/>
           </a:xfrm>
           <a:prstGeom prst="rect">
             <a:avLst/>
@@ -11155,6 +12012,584 @@
 </file>
 
 <file path=ppt/slides/slide7.xml><?xml version="1.0" encoding="utf-8"?>
+<p:sld xmlns:a="http://schemas.openxmlformats.org/drawingml/2006/main" xmlns:p="http://schemas.openxmlformats.org/presentationml/2006/main" xmlns:r="http://schemas.openxmlformats.org/officeDocument/2006/relationships">
+  <p:cSld>
+    <p:spTree>
+      <p:nvGrpSpPr>
+        <p:cNvPr id="1" name=""/>
+        <p:cNvGrpSpPr/>
+        <p:nvPr/>
+      </p:nvGrpSpPr>
+      <p:grpSpPr/>
+      <p:sp>
+        <p:nvSpPr>
+          <p:cNvPr id="2" name="Rectangle 1"/>
+          <p:cNvSpPr/>
+          <p:nvPr/>
+        </p:nvSpPr>
+        <p:spPr>
+          <a:xfrm>
+            <a:off x="0" y="0"/>
+            <a:ext cx="12191695" cy="6858000"/>
+          </a:xfrm>
+          <a:prstGeom prst="rect">
+            <a:avLst/>
+          </a:prstGeom>
+          <a:solidFill>
+            <a:srgbClr val="FFFFFF"/>
+          </a:solidFill>
+          <a:ln>
+            <a:noFill/>
+          </a:ln>
+        </p:spPr>
+        <p:style>
+          <a:lnRef idx="1">
+            <a:schemeClr val="accent1"/>
+          </a:lnRef>
+          <a:fillRef idx="3">
+            <a:schemeClr val="accent1"/>
+          </a:fillRef>
+          <a:effectRef idx="2">
+            <a:schemeClr val="accent1"/>
+          </a:effectRef>
+          <a:fontRef idx="minor">
+            <a:schemeClr val="lt1"/>
+          </a:fontRef>
+        </p:style>
+        <p:txBody>
+          <a:bodyPr rtlCol="0" anchor="ctr"/>
+          <a:lstStyle/>
+          <a:p>
+            <a:pPr algn="ctr"/>
+          </a:p>
+        </p:txBody>
+      </p:sp>
+      <p:sp>
+        <p:nvSpPr>
+          <p:cNvPr id="3" name="Rectangle 2"/>
+          <p:cNvSpPr/>
+          <p:nvPr/>
+        </p:nvSpPr>
+        <p:spPr>
+          <a:xfrm>
+            <a:off x="0" y="0"/>
+            <a:ext cx="12191695" cy="109728"/>
+          </a:xfrm>
+          <a:prstGeom prst="rect">
+            <a:avLst/>
+          </a:prstGeom>
+          <a:solidFill>
+            <a:srgbClr val="F2A30A"/>
+          </a:solidFill>
+          <a:ln>
+            <a:noFill/>
+          </a:ln>
+        </p:spPr>
+        <p:style>
+          <a:lnRef idx="1">
+            <a:schemeClr val="accent1"/>
+          </a:lnRef>
+          <a:fillRef idx="3">
+            <a:schemeClr val="accent1"/>
+          </a:fillRef>
+          <a:effectRef idx="2">
+            <a:schemeClr val="accent1"/>
+          </a:effectRef>
+          <a:fontRef idx="minor">
+            <a:schemeClr val="lt1"/>
+          </a:fontRef>
+        </p:style>
+        <p:txBody>
+          <a:bodyPr rtlCol="0" anchor="ctr"/>
+          <a:lstStyle/>
+          <a:p>
+            <a:pPr algn="ctr"/>
+          </a:p>
+        </p:txBody>
+      </p:sp>
+      <p:sp>
+        <p:nvSpPr>
+          <p:cNvPr id="4" name="Rectangle 3"/>
+          <p:cNvSpPr/>
+          <p:nvPr/>
+        </p:nvSpPr>
+        <p:spPr>
+          <a:xfrm>
+            <a:off x="0" y="6583680"/>
+            <a:ext cx="12191695" cy="274320"/>
+          </a:xfrm>
+          <a:prstGeom prst="rect">
+            <a:avLst/>
+          </a:prstGeom>
+          <a:solidFill>
+            <a:srgbClr val="0F233E"/>
+          </a:solidFill>
+          <a:ln>
+            <a:noFill/>
+          </a:ln>
+        </p:spPr>
+        <p:style>
+          <a:lnRef idx="1">
+            <a:schemeClr val="accent1"/>
+          </a:lnRef>
+          <a:fillRef idx="3">
+            <a:schemeClr val="accent1"/>
+          </a:fillRef>
+          <a:effectRef idx="2">
+            <a:schemeClr val="accent1"/>
+          </a:effectRef>
+          <a:fontRef idx="minor">
+            <a:schemeClr val="lt1"/>
+          </a:fontRef>
+        </p:style>
+        <p:txBody>
+          <a:bodyPr rtlCol="0" anchor="ctr" wrap="none"/>
+          <a:lstStyle/>
+          <a:p>
+            <a:pPr algn="r"/>
+            <a:r>
+              <a:rPr sz="1200" b="0">
+                <a:solidFill>
+                  <a:srgbClr val="FFFFFF"/>
+                </a:solidFill>
+                <a:ea typeface="TH Sarabun New"/>
+                <a:cs typeface="TH Sarabun New"/>
+                <a:latin typeface="TH Sarabun New"/>
+              </a:rPr>
+              <a:t>TOR Generator  v0.2.3   ·   รายงานการทำงาน   ·   20 ส.ค. 2026</a:t>
+            </a:r>
+          </a:p>
+        </p:txBody>
+      </p:sp>
+      <p:sp>
+        <p:nvSpPr>
+          <p:cNvPr id="5" name="TextBox 4"/>
+          <p:cNvSpPr txBox="1"/>
+          <p:nvPr/>
+        </p:nvSpPr>
+        <p:spPr>
+          <a:xfrm>
+            <a:off x="457200" y="256032"/>
+            <a:ext cx="11247120" cy="457200"/>
+          </a:xfrm>
+          <a:prstGeom prst="rect">
+            <a:avLst/>
+          </a:prstGeom>
+          <a:noFill/>
+        </p:spPr>
+        <p:txBody>
+          <a:bodyPr wrap="square">
+            <a:spAutoFit/>
+          </a:bodyPr>
+          <a:lstStyle/>
+          <a:p>
+            <a:pPr algn="l"/>
+            <a:r>
+              <a:rPr sz="2600" b="1">
+                <a:solidFill>
+                  <a:srgbClr val="1D408C"/>
+                </a:solidFill>
+                <a:ea typeface="TH Sarabun New"/>
+                <a:cs typeface="TH Sarabun New"/>
+                <a:latin typeface="TH Sarabun New"/>
+              </a:rPr>
+              <a:t>สามเครื่องมือหลักของเจ้าหน้าที่</a:t>
+            </a:r>
+          </a:p>
+        </p:txBody>
+      </p:sp>
+      <p:graphicFrame>
+        <p:nvGraphicFramePr>
+          <p:cNvPr id="6" name="Table 5"/>
+          <p:cNvGraphicFramePr>
+            <a:graphicFrameLocks noGrp="1"/>
+          </p:cNvGraphicFramePr>
+          <p:nvPr/>
+        </p:nvGraphicFramePr>
+        <p:xfrm>
+          <a:off x="457200" y="960120"/>
+          <a:ext cx="11247120" cy="2743200"/>
+        </p:xfrm>
+        <a:graphic>
+          <a:graphicData uri="http://schemas.openxmlformats.org/drawingml/2006/table">
+            <a:tbl>
+              <a:tblPr firstRow="1" bandRow="1">
+                <a:tableStyleId>{5C22544A-7EE6-4342-B048-85BDC9FD1C3A}</a:tableStyleId>
+              </a:tblPr>
+              <a:tblGrid>
+                <a:gridCol w="3749040"/>
+                <a:gridCol w="3749040"/>
+                <a:gridCol w="3749040"/>
+              </a:tblGrid>
+              <a:tr h="685800">
+                <a:tc>
+                  <a:txBody>
+                    <a:bodyPr wrap="square"/>
+                    <a:lstStyle/>
+                    <a:p>
+                      <a:pPr algn="l"/>
+                      <a:r>
+                        <a:rPr sz="1600" b="1">
+                          <a:solidFill>
+                            <a:srgbClr val="FFFFFF"/>
+                          </a:solidFill>
+                          <a:ea typeface="TH Sarabun New"/>
+                          <a:cs typeface="TH Sarabun New"/>
+                          <a:latin typeface="TH Sarabun New"/>
+                        </a:rPr>
+                        <a:t>เครื่องมือ</a:t>
+                      </a:r>
+                    </a:p>
+                  </a:txBody>
+                  <a:tcPr anchor="ctr">
+                    <a:solidFill>
+                      <a:srgbClr val="1D408C"/>
+                    </a:solidFill>
+                  </a:tcPr>
+                </a:tc>
+                <a:tc>
+                  <a:txBody>
+                    <a:bodyPr wrap="square"/>
+                    <a:lstStyle/>
+                    <a:p>
+                      <a:pPr algn="l"/>
+                      <a:r>
+                        <a:rPr sz="1600" b="1">
+                          <a:solidFill>
+                            <a:srgbClr val="FFFFFF"/>
+                          </a:solidFill>
+                          <a:ea typeface="TH Sarabun New"/>
+                          <a:cs typeface="TH Sarabun New"/>
+                          <a:latin typeface="TH Sarabun New"/>
+                        </a:rPr>
+                        <a:t>หน้า</a:t>
+                      </a:r>
+                    </a:p>
+                  </a:txBody>
+                  <a:tcPr anchor="ctr">
+                    <a:solidFill>
+                      <a:srgbClr val="1D408C"/>
+                    </a:solidFill>
+                  </a:tcPr>
+                </a:tc>
+                <a:tc>
+                  <a:txBody>
+                    <a:bodyPr wrap="square"/>
+                    <a:lstStyle/>
+                    <a:p>
+                      <a:pPr algn="l"/>
+                      <a:r>
+                        <a:rPr sz="1600" b="1">
+                          <a:solidFill>
+                            <a:srgbClr val="FFFFFF"/>
+                          </a:solidFill>
+                          <a:ea typeface="TH Sarabun New"/>
+                          <a:cs typeface="TH Sarabun New"/>
+                          <a:latin typeface="TH Sarabun New"/>
+                        </a:rPr>
+                        <a:t>ผลที่ควรเห็น</a:t>
+                      </a:r>
+                    </a:p>
+                  </a:txBody>
+                  <a:tcPr anchor="ctr">
+                    <a:solidFill>
+                      <a:srgbClr val="1D408C"/>
+                    </a:solidFill>
+                  </a:tcPr>
+                </a:tc>
+              </a:tr>
+              <a:tr h="685800">
+                <a:tc>
+                  <a:txBody>
+                    <a:bodyPr wrap="square"/>
+                    <a:lstStyle/>
+                    <a:p>
+                      <a:pPr algn="l"/>
+                      <a:r>
+                        <a:rPr sz="1500" b="0">
+                          <a:solidFill>
+                            <a:srgbClr val="1F2A37"/>
+                          </a:solidFill>
+                          <a:ea typeface="TH Sarabun New"/>
+                          <a:cs typeface="TH Sarabun New"/>
+                          <a:latin typeface="TH Sarabun New"/>
+                        </a:rPr>
+                        <a:t>ร่าง TOR</a:t>
+                      </a:r>
+                    </a:p>
+                  </a:txBody>
+                  <a:tcPr anchor="ctr">
+                    <a:solidFill>
+                      <a:srgbClr val="F4F7FB"/>
+                    </a:solidFill>
+                  </a:tcPr>
+                </a:tc>
+                <a:tc>
+                  <a:txBody>
+                    <a:bodyPr wrap="square"/>
+                    <a:lstStyle/>
+                    <a:p>
+                      <a:pPr algn="l"/>
+                      <a:r>
+                        <a:rPr sz="1500" b="0">
+                          <a:solidFill>
+                            <a:srgbClr val="1F2A37"/>
+                          </a:solidFill>
+                          <a:ea typeface="TH Sarabun New"/>
+                          <a:cs typeface="TH Sarabun New"/>
+                          <a:latin typeface="TH Sarabun New"/>
+                        </a:rPr>
+                        <a:t>/projects/{id}/draft · 5 Phase</a:t>
+                      </a:r>
+                    </a:p>
+                  </a:txBody>
+                  <a:tcPr anchor="ctr">
+                    <a:solidFill>
+                      <a:srgbClr val="F4F7FB"/>
+                    </a:solidFill>
+                  </a:tcPr>
+                </a:tc>
+                <a:tc>
+                  <a:txBody>
+                    <a:bodyPr wrap="square"/>
+                    <a:lstStyle/>
+                    <a:p>
+                      <a:pPr algn="l"/>
+                      <a:r>
+                        <a:rPr sz="1500" b="0">
+                          <a:solidFill>
+                            <a:srgbClr val="1F2A37"/>
+                          </a:solidFill>
+                          <a:ea typeface="TH Sarabun New"/>
+                          <a:cs typeface="TH Sarabun New"/>
+                          <a:latin typeface="TH Sarabun New"/>
+                        </a:rPr>
+                        <a:t>เนื้อหา s1–s13 พร้อมส่งตรวจ</a:t>
+                      </a:r>
+                    </a:p>
+                  </a:txBody>
+                  <a:tcPr anchor="ctr">
+                    <a:solidFill>
+                      <a:srgbClr val="F4F7FB"/>
+                    </a:solidFill>
+                  </a:tcPr>
+                </a:tc>
+              </a:tr>
+              <a:tr h="685800">
+                <a:tc>
+                  <a:txBody>
+                    <a:bodyPr wrap="square"/>
+                    <a:lstStyle/>
+                    <a:p>
+                      <a:pPr algn="l"/>
+                      <a:r>
+                        <a:rPr sz="1500" b="0">
+                          <a:solidFill>
+                            <a:srgbClr val="1F2A37"/>
+                          </a:solidFill>
+                          <a:ea typeface="TH Sarabun New"/>
+                          <a:cs typeface="TH Sarabun New"/>
+                          <a:latin typeface="TH Sarabun New"/>
+                        </a:rPr>
+                        <a:t>ตรวจสอบ TOR</a:t>
+                      </a:r>
+                    </a:p>
+                  </a:txBody>
+                  <a:tcPr anchor="ctr">
+                    <a:solidFill>
+                      <a:srgbClr val="FFFFFF"/>
+                    </a:solidFill>
+                  </a:tcPr>
+                </a:tc>
+                <a:tc>
+                  <a:txBody>
+                    <a:bodyPr wrap="square"/>
+                    <a:lstStyle/>
+                    <a:p>
+                      <a:pPr algn="l"/>
+                      <a:r>
+                        <a:rPr sz="1500" b="0">
+                          <a:solidFill>
+                            <a:srgbClr val="1F2A37"/>
+                          </a:solidFill>
+                          <a:ea typeface="TH Sarabun New"/>
+                          <a:cs typeface="TH Sarabun New"/>
+                          <a:latin typeface="TH Sarabun New"/>
+                        </a:rPr>
+                        <a:t>Phase 3 + /review</a:t>
+                      </a:r>
+                    </a:p>
+                  </a:txBody>
+                  <a:tcPr anchor="ctr">
+                    <a:solidFill>
+                      <a:srgbClr val="FFFFFF"/>
+                    </a:solidFill>
+                  </a:tcPr>
+                </a:tc>
+                <a:tc>
+                  <a:txBody>
+                    <a:bodyPr wrap="square"/>
+                    <a:lstStyle/>
+                    <a:p>
+                      <a:pPr algn="l"/>
+                      <a:r>
+                        <a:rPr sz="1500" b="0">
+                          <a:solidFill>
+                            <a:srgbClr val="1F2A37"/>
+                          </a:solidFill>
+                          <a:ea typeface="TH Sarabun New"/>
+                          <a:cs typeface="TH Sarabun New"/>
+                          <a:latin typeface="TH Sarabun New"/>
+                        </a:rPr>
+                        <a:t>คะแนน ≥70 / findings / suggestions</a:t>
+                      </a:r>
+                    </a:p>
+                  </a:txBody>
+                  <a:tcPr anchor="ctr">
+                    <a:solidFill>
+                      <a:srgbClr val="FFFFFF"/>
+                    </a:solidFill>
+                  </a:tcPr>
+                </a:tc>
+              </a:tr>
+              <a:tr h="685800">
+                <a:tc>
+                  <a:txBody>
+                    <a:bodyPr wrap="square"/>
+                    <a:lstStyle/>
+                    <a:p>
+                      <a:pPr algn="l"/>
+                      <a:r>
+                        <a:rPr sz="1500" b="0">
+                          <a:solidFill>
+                            <a:srgbClr val="1F2A37"/>
+                          </a:solidFill>
+                          <a:ea typeface="TH Sarabun New"/>
+                          <a:cs typeface="TH Sarabun New"/>
+                          <a:latin typeface="TH Sarabun New"/>
+                        </a:rPr>
+                        <a:t>ถาม-ตอบ</a:t>
+                      </a:r>
+                    </a:p>
+                  </a:txBody>
+                  <a:tcPr anchor="ctr">
+                    <a:solidFill>
+                      <a:srgbClr val="F4F7FB"/>
+                    </a:solidFill>
+                  </a:tcPr>
+                </a:tc>
+                <a:tc>
+                  <a:txBody>
+                    <a:bodyPr wrap="square"/>
+                    <a:lstStyle/>
+                    <a:p>
+                      <a:pPr algn="l"/>
+                      <a:r>
+                        <a:rPr sz="1500" b="0">
+                          <a:solidFill>
+                            <a:srgbClr val="1F2A37"/>
+                          </a:solidFill>
+                          <a:ea typeface="TH Sarabun New"/>
+                          <a:cs typeface="TH Sarabun New"/>
+                          <a:latin typeface="TH Sarabun New"/>
+                        </a:rPr>
+                        <a:t>/chat (SSE + citations)</a:t>
+                      </a:r>
+                    </a:p>
+                  </a:txBody>
+                  <a:tcPr anchor="ctr">
+                    <a:solidFill>
+                      <a:srgbClr val="F4F7FB"/>
+                    </a:solidFill>
+                  </a:tcPr>
+                </a:tc>
+                <a:tc>
+                  <a:txBody>
+                    <a:bodyPr wrap="square"/>
+                    <a:lstStyle/>
+                    <a:p>
+                      <a:pPr algn="l"/>
+                      <a:r>
+                        <a:rPr sz="1500" b="0">
+                          <a:solidFill>
+                            <a:srgbClr val="1F2A37"/>
+                          </a:solidFill>
+                          <a:ea typeface="TH Sarabun New"/>
+                          <a:cs typeface="TH Sarabun New"/>
+                          <a:latin typeface="TH Sarabun New"/>
+                        </a:rPr>
+                        <a:t>คำตอบยาวพร้อมชิปอ้างอิงจากคลัง</a:t>
+                      </a:r>
+                    </a:p>
+                  </a:txBody>
+                  <a:tcPr anchor="ctr">
+                    <a:solidFill>
+                      <a:srgbClr val="F4F7FB"/>
+                    </a:solidFill>
+                  </a:tcPr>
+                </a:tc>
+              </a:tr>
+            </a:tbl>
+          </a:graphicData>
+        </a:graphic>
+      </p:graphicFrame>
+      <p:pic>
+        <p:nvPicPr>
+          <p:cNvPr id="7" name="Picture 6" descr="13-kb-chat.png"/>
+          <p:cNvPicPr>
+            <a:picLocks noChangeAspect="1"/>
+          </p:cNvPicPr>
+          <p:nvPr/>
+        </p:nvPicPr>
+        <p:blipFill>
+          <a:blip r:embed="rId2"/>
+          <a:stretch>
+            <a:fillRect/>
+          </a:stretch>
+        </p:blipFill>
+        <p:spPr>
+          <a:xfrm>
+            <a:off x="502920" y="3931920"/>
+            <a:ext cx="5303520" cy="3314700"/>
+          </a:xfrm>
+          <a:prstGeom prst="rect">
+            <a:avLst/>
+          </a:prstGeom>
+        </p:spPr>
+      </p:pic>
+      <p:pic>
+        <p:nvPicPr>
+          <p:cNvPr id="8" name="Picture 7" descr="12-standalone-review.png"/>
+          <p:cNvPicPr>
+            <a:picLocks noChangeAspect="1"/>
+          </p:cNvPicPr>
+          <p:nvPr/>
+        </p:nvPicPr>
+        <p:blipFill>
+          <a:blip r:embed="rId3"/>
+          <a:stretch>
+            <a:fillRect/>
+          </a:stretch>
+        </p:blipFill>
+        <p:spPr>
+          <a:xfrm>
+            <a:off x="6035040" y="3931920"/>
+            <a:ext cx="5303520" cy="3314700"/>
+          </a:xfrm>
+          <a:prstGeom prst="rect">
+            <a:avLst/>
+          </a:prstGeom>
+        </p:spPr>
+      </p:pic>
+    </p:spTree>
+  </p:cSld>
+  <p:clrMapOvr>
+    <a:masterClrMapping/>
+  </p:clrMapOvr>
+</p:sld>
+</file>
+
+<file path=ppt/slides/slide8.xml><?xml version="1.0" encoding="utf-8"?>
 <p:sld xmlns:a="http://schemas.openxmlformats.org/drawingml/2006/main" xmlns:p="http://schemas.openxmlformats.org/presentationml/2006/main" xmlns:r="http://schemas.openxmlformats.org/officeDocument/2006/relationships">
   <p:cSld>
     <p:spTree>
@@ -11687,7 +13122,7 @@
 </p:sld>
 </file>
 
-<file path=ppt/slides/slide8.xml><?xml version="1.0" encoding="utf-8"?>
+<file path=ppt/slides/slide9.xml><?xml version="1.0" encoding="utf-8"?>
 <p:sld xmlns:a="http://schemas.openxmlformats.org/drawingml/2006/main" xmlns:p="http://schemas.openxmlformats.org/presentationml/2006/main" xmlns:r="http://schemas.openxmlformats.org/officeDocument/2006/relationships">
   <p:cSld>
     <p:spTree>
@@ -12503,844 +13938,6 @@
                           <a:latin typeface="TH Sarabun New"/>
                         </a:rPr>
                         <a:t>DOCX PDF ไทย MinIO</a:t>
-                      </a:r>
-                    </a:p>
-                  </a:txBody>
-                  <a:tcPr anchor="ctr">
-                    <a:solidFill>
-                      <a:srgbClr val="F4F7FB"/>
-                    </a:solidFill>
-                  </a:tcPr>
-                </a:tc>
-              </a:tr>
-            </a:tbl>
-          </a:graphicData>
-        </a:graphic>
-      </p:graphicFrame>
-    </p:spTree>
-  </p:cSld>
-  <p:clrMapOvr>
-    <a:masterClrMapping/>
-  </p:clrMapOvr>
-</p:sld>
-</file>
-
-<file path=ppt/slides/slide9.xml><?xml version="1.0" encoding="utf-8"?>
-<p:sld xmlns:a="http://schemas.openxmlformats.org/drawingml/2006/main" xmlns:p="http://schemas.openxmlformats.org/presentationml/2006/main" xmlns:r="http://schemas.openxmlformats.org/officeDocument/2006/relationships">
-  <p:cSld>
-    <p:spTree>
-      <p:nvGrpSpPr>
-        <p:cNvPr id="1" name=""/>
-        <p:cNvGrpSpPr/>
-        <p:nvPr/>
-      </p:nvGrpSpPr>
-      <p:grpSpPr/>
-      <p:sp>
-        <p:nvSpPr>
-          <p:cNvPr id="2" name="Rectangle 1"/>
-          <p:cNvSpPr/>
-          <p:nvPr/>
-        </p:nvSpPr>
-        <p:spPr>
-          <a:xfrm>
-            <a:off x="0" y="0"/>
-            <a:ext cx="12191695" cy="6858000"/>
-          </a:xfrm>
-          <a:prstGeom prst="rect">
-            <a:avLst/>
-          </a:prstGeom>
-          <a:solidFill>
-            <a:srgbClr val="FFFFFF"/>
-          </a:solidFill>
-          <a:ln>
-            <a:noFill/>
-          </a:ln>
-        </p:spPr>
-        <p:style>
-          <a:lnRef idx="1">
-            <a:schemeClr val="accent1"/>
-          </a:lnRef>
-          <a:fillRef idx="3">
-            <a:schemeClr val="accent1"/>
-          </a:fillRef>
-          <a:effectRef idx="2">
-            <a:schemeClr val="accent1"/>
-          </a:effectRef>
-          <a:fontRef idx="minor">
-            <a:schemeClr val="lt1"/>
-          </a:fontRef>
-        </p:style>
-        <p:txBody>
-          <a:bodyPr rtlCol="0" anchor="ctr"/>
-          <a:lstStyle/>
-          <a:p>
-            <a:pPr algn="ctr"/>
-          </a:p>
-        </p:txBody>
-      </p:sp>
-      <p:sp>
-        <p:nvSpPr>
-          <p:cNvPr id="3" name="Rectangle 2"/>
-          <p:cNvSpPr/>
-          <p:nvPr/>
-        </p:nvSpPr>
-        <p:spPr>
-          <a:xfrm>
-            <a:off x="0" y="0"/>
-            <a:ext cx="12191695" cy="109728"/>
-          </a:xfrm>
-          <a:prstGeom prst="rect">
-            <a:avLst/>
-          </a:prstGeom>
-          <a:solidFill>
-            <a:srgbClr val="F2A30A"/>
-          </a:solidFill>
-          <a:ln>
-            <a:noFill/>
-          </a:ln>
-        </p:spPr>
-        <p:style>
-          <a:lnRef idx="1">
-            <a:schemeClr val="accent1"/>
-          </a:lnRef>
-          <a:fillRef idx="3">
-            <a:schemeClr val="accent1"/>
-          </a:fillRef>
-          <a:effectRef idx="2">
-            <a:schemeClr val="accent1"/>
-          </a:effectRef>
-          <a:fontRef idx="minor">
-            <a:schemeClr val="lt1"/>
-          </a:fontRef>
-        </p:style>
-        <p:txBody>
-          <a:bodyPr rtlCol="0" anchor="ctr"/>
-          <a:lstStyle/>
-          <a:p>
-            <a:pPr algn="ctr"/>
-          </a:p>
-        </p:txBody>
-      </p:sp>
-      <p:sp>
-        <p:nvSpPr>
-          <p:cNvPr id="4" name="Rectangle 3"/>
-          <p:cNvSpPr/>
-          <p:nvPr/>
-        </p:nvSpPr>
-        <p:spPr>
-          <a:xfrm>
-            <a:off x="0" y="6583680"/>
-            <a:ext cx="12191695" cy="274320"/>
-          </a:xfrm>
-          <a:prstGeom prst="rect">
-            <a:avLst/>
-          </a:prstGeom>
-          <a:solidFill>
-            <a:srgbClr val="0F233E"/>
-          </a:solidFill>
-          <a:ln>
-            <a:noFill/>
-          </a:ln>
-        </p:spPr>
-        <p:style>
-          <a:lnRef idx="1">
-            <a:schemeClr val="accent1"/>
-          </a:lnRef>
-          <a:fillRef idx="3">
-            <a:schemeClr val="accent1"/>
-          </a:fillRef>
-          <a:effectRef idx="2">
-            <a:schemeClr val="accent1"/>
-          </a:effectRef>
-          <a:fontRef idx="minor">
-            <a:schemeClr val="lt1"/>
-          </a:fontRef>
-        </p:style>
-        <p:txBody>
-          <a:bodyPr rtlCol="0" anchor="ctr" wrap="none"/>
-          <a:lstStyle/>
-          <a:p>
-            <a:pPr algn="r"/>
-            <a:r>
-              <a:rPr sz="1200" b="0">
-                <a:solidFill>
-                  <a:srgbClr val="FFFFFF"/>
-                </a:solidFill>
-                <a:ea typeface="TH Sarabun New"/>
-                <a:cs typeface="TH Sarabun New"/>
-                <a:latin typeface="TH Sarabun New"/>
-              </a:rPr>
-              <a:t>TOR Generator  v0.2.3   ·   รายงานการทำงาน   ·   20 ส.ค. 2026</a:t>
-            </a:r>
-          </a:p>
-        </p:txBody>
-      </p:sp>
-      <p:sp>
-        <p:nvSpPr>
-          <p:cNvPr id="5" name="TextBox 4"/>
-          <p:cNvSpPr txBox="1"/>
-          <p:nvPr/>
-        </p:nvSpPr>
-        <p:spPr>
-          <a:xfrm>
-            <a:off x="457200" y="256032"/>
-            <a:ext cx="11247120" cy="457200"/>
-          </a:xfrm>
-          <a:prstGeom prst="rect">
-            <a:avLst/>
-          </a:prstGeom>
-          <a:noFill/>
-        </p:spPr>
-        <p:txBody>
-          <a:bodyPr wrap="square">
-            <a:spAutoFit/>
-          </a:bodyPr>
-          <a:lstStyle/>
-          <a:p>
-            <a:pPr algn="l"/>
-            <a:r>
-              <a:rPr sz="2600" b="1">
-                <a:solidFill>
-                  <a:srgbClr val="1D408C"/>
-                </a:solidFill>
-                <a:ea typeface="TH Sarabun New"/>
-                <a:cs typeface="TH Sarabun New"/>
-                <a:latin typeface="TH Sarabun New"/>
-              </a:rPr>
-              <a:t>13 หมวด TOR และจุด HITL</a:t>
-            </a:r>
-          </a:p>
-        </p:txBody>
-      </p:sp>
-      <p:graphicFrame>
-        <p:nvGraphicFramePr>
-          <p:cNvPr id="6" name="Table 5"/>
-          <p:cNvGraphicFramePr>
-            <a:graphicFrameLocks noGrp="1"/>
-          </p:cNvGraphicFramePr>
-          <p:nvPr/>
-        </p:nvGraphicFramePr>
-        <p:xfrm>
-          <a:off x="457200" y="960120"/>
-          <a:ext cx="11247120" cy="4754880"/>
-        </p:xfrm>
-        <a:graphic>
-          <a:graphicData uri="http://schemas.openxmlformats.org/drawingml/2006/table">
-            <a:tbl>
-              <a:tblPr firstRow="1" bandRow="1">
-                <a:tableStyleId>{5C22544A-7EE6-4342-B048-85BDC9FD1C3A}</a:tableStyleId>
-              </a:tblPr>
-              <a:tblGrid>
-                <a:gridCol w="3749040"/>
-                <a:gridCol w="3749040"/>
-                <a:gridCol w="3749040"/>
-              </a:tblGrid>
-              <a:tr h="594360">
-                <a:tc>
-                  <a:txBody>
-                    <a:bodyPr wrap="square"/>
-                    <a:lstStyle/>
-                    <a:p>
-                      <a:pPr algn="l"/>
-                      <a:r>
-                        <a:rPr sz="1400" b="1">
-                          <a:solidFill>
-                            <a:srgbClr val="FFFFFF"/>
-                          </a:solidFill>
-                          <a:ea typeface="TH Sarabun New"/>
-                          <a:cs typeface="TH Sarabun New"/>
-                          <a:latin typeface="TH Sarabun New"/>
-                        </a:rPr>
-                        <a:t>คีย์</a:t>
-                      </a:r>
-                    </a:p>
-                  </a:txBody>
-                  <a:tcPr anchor="ctr">
-                    <a:solidFill>
-                      <a:srgbClr val="1D408C"/>
-                    </a:solidFill>
-                  </a:tcPr>
-                </a:tc>
-                <a:tc>
-                  <a:txBody>
-                    <a:bodyPr wrap="square"/>
-                    <a:lstStyle/>
-                    <a:p>
-                      <a:pPr algn="l"/>
-                      <a:r>
-                        <a:rPr sz="1400" b="1">
-                          <a:solidFill>
-                            <a:srgbClr val="FFFFFF"/>
-                          </a:solidFill>
-                          <a:ea typeface="TH Sarabun New"/>
-                          <a:cs typeface="TH Sarabun New"/>
-                          <a:latin typeface="TH Sarabun New"/>
-                        </a:rPr>
-                        <a:t>ชื่อ</a:t>
-                      </a:r>
-                    </a:p>
-                  </a:txBody>
-                  <a:tcPr anchor="ctr">
-                    <a:solidFill>
-                      <a:srgbClr val="1D408C"/>
-                    </a:solidFill>
-                  </a:tcPr>
-                </a:tc>
-                <a:tc>
-                  <a:txBody>
-                    <a:bodyPr wrap="square"/>
-                    <a:lstStyle/>
-                    <a:p>
-                      <a:pPr algn="l"/>
-                      <a:r>
-                        <a:rPr sz="1400" b="1">
-                          <a:solidFill>
-                            <a:srgbClr val="FFFFFF"/>
-                          </a:solidFill>
-                          <a:ea typeface="TH Sarabun New"/>
-                          <a:cs typeface="TH Sarabun New"/>
-                          <a:latin typeface="TH Sarabun New"/>
-                        </a:rPr>
-                        <a:t>ต้องคนยืนยัน</a:t>
-                      </a:r>
-                    </a:p>
-                  </a:txBody>
-                  <a:tcPr anchor="ctr">
-                    <a:solidFill>
-                      <a:srgbClr val="1D408C"/>
-                    </a:solidFill>
-                  </a:tcPr>
-                </a:tc>
-              </a:tr>
-              <a:tr h="594360">
-                <a:tc>
-                  <a:txBody>
-                    <a:bodyPr wrap="square"/>
-                    <a:lstStyle/>
-                    <a:p>
-                      <a:pPr algn="l"/>
-                      <a:r>
-                        <a:rPr sz="1300" b="0">
-                          <a:solidFill>
-                            <a:srgbClr val="1F2A37"/>
-                          </a:solidFill>
-                          <a:ea typeface="TH Sarabun New"/>
-                          <a:cs typeface="TH Sarabun New"/>
-                          <a:latin typeface="TH Sarabun New"/>
-                        </a:rPr>
-                        <a:t>s1 / s2</a:t>
-                      </a:r>
-                    </a:p>
-                  </a:txBody>
-                  <a:tcPr anchor="ctr">
-                    <a:solidFill>
-                      <a:srgbClr val="F4F7FB"/>
-                    </a:solidFill>
-                  </a:tcPr>
-                </a:tc>
-                <a:tc>
-                  <a:txBody>
-                    <a:bodyPr wrap="square"/>
-                    <a:lstStyle/>
-                    <a:p>
-                      <a:pPr algn="l"/>
-                      <a:r>
-                        <a:rPr sz="1300" b="0">
-                          <a:solidFill>
-                            <a:srgbClr val="1F2A37"/>
-                          </a:solidFill>
-                          <a:ea typeface="TH Sarabun New"/>
-                          <a:cs typeface="TH Sarabun New"/>
-                          <a:latin typeface="TH Sarabun New"/>
-                        </a:rPr>
-                        <a:t>ความเป็นมา / วัตถุประสงค์</a:t>
-                      </a:r>
-                    </a:p>
-                  </a:txBody>
-                  <a:tcPr anchor="ctr">
-                    <a:solidFill>
-                      <a:srgbClr val="F4F7FB"/>
-                    </a:solidFill>
-                  </a:tcPr>
-                </a:tc>
-                <a:tc>
-                  <a:txBody>
-                    <a:bodyPr wrap="square"/>
-                    <a:lstStyle/>
-                    <a:p>
-                      <a:pPr algn="l"/>
-                      <a:r>
-                        <a:rPr sz="1300" b="0">
-                          <a:solidFill>
-                            <a:srgbClr val="1F2A37"/>
-                          </a:solidFill>
-                          <a:ea typeface="TH Sarabun New"/>
-                          <a:cs typeface="TH Sarabun New"/>
-                          <a:latin typeface="TH Sarabun New"/>
-                        </a:rPr>
-                        <a:t>ไม่</a:t>
-                      </a:r>
-                    </a:p>
-                  </a:txBody>
-                  <a:tcPr anchor="ctr">
-                    <a:solidFill>
-                      <a:srgbClr val="F4F7FB"/>
-                    </a:solidFill>
-                  </a:tcPr>
-                </a:tc>
-              </a:tr>
-              <a:tr h="594360">
-                <a:tc>
-                  <a:txBody>
-                    <a:bodyPr wrap="square"/>
-                    <a:lstStyle/>
-                    <a:p>
-                      <a:pPr algn="l"/>
-                      <a:r>
-                        <a:rPr sz="1300" b="0">
-                          <a:solidFill>
-                            <a:srgbClr val="1F2A37"/>
-                          </a:solidFill>
-                          <a:ea typeface="TH Sarabun New"/>
-                          <a:cs typeface="TH Sarabun New"/>
-                          <a:latin typeface="TH Sarabun New"/>
-                        </a:rPr>
-                        <a:t>s3</a:t>
-                      </a:r>
-                    </a:p>
-                  </a:txBody>
-                  <a:tcPr anchor="ctr">
-                    <a:solidFill>
-                      <a:srgbClr val="FFFFFF"/>
-                    </a:solidFill>
-                  </a:tcPr>
-                </a:tc>
-                <a:tc>
-                  <a:txBody>
-                    <a:bodyPr wrap="square"/>
-                    <a:lstStyle/>
-                    <a:p>
-                      <a:pPr algn="l"/>
-                      <a:r>
-                        <a:rPr sz="1300" b="0">
-                          <a:solidFill>
-                            <a:srgbClr val="1F2A37"/>
-                          </a:solidFill>
-                          <a:ea typeface="TH Sarabun New"/>
-                          <a:cs typeface="TH Sarabun New"/>
-                          <a:latin typeface="TH Sarabun New"/>
-                        </a:rPr>
-                        <a:t>คุณสมบัติผู้เสนอราคา</a:t>
-                      </a:r>
-                    </a:p>
-                  </a:txBody>
-                  <a:tcPr anchor="ctr">
-                    <a:solidFill>
-                      <a:srgbClr val="FFFFFF"/>
-                    </a:solidFill>
-                  </a:tcPr>
-                </a:tc>
-                <a:tc>
-                  <a:txBody>
-                    <a:bodyPr wrap="square"/>
-                    <a:lstStyle/>
-                    <a:p>
-                      <a:pPr algn="l"/>
-                      <a:r>
-                        <a:rPr sz="1300" b="0">
-                          <a:solidFill>
-                            <a:srgbClr val="1F2A37"/>
-                          </a:solidFill>
-                          <a:ea typeface="TH Sarabun New"/>
-                          <a:cs typeface="TH Sarabun New"/>
-                          <a:latin typeface="TH Sarabun New"/>
-                        </a:rPr>
-                        <a:t>ใช่</a:t>
-                      </a:r>
-                    </a:p>
-                  </a:txBody>
-                  <a:tcPr anchor="ctr">
-                    <a:solidFill>
-                      <a:srgbClr val="FFFFFF"/>
-                    </a:solidFill>
-                  </a:tcPr>
-                </a:tc>
-              </a:tr>
-              <a:tr h="594360">
-                <a:tc>
-                  <a:txBody>
-                    <a:bodyPr wrap="square"/>
-                    <a:lstStyle/>
-                    <a:p>
-                      <a:pPr algn="l"/>
-                      <a:r>
-                        <a:rPr sz="1300" b="0">
-                          <a:solidFill>
-                            <a:srgbClr val="1F2A37"/>
-                          </a:solidFill>
-                          <a:ea typeface="TH Sarabun New"/>
-                          <a:cs typeface="TH Sarabun New"/>
-                          <a:latin typeface="TH Sarabun New"/>
-                        </a:rPr>
-                        <a:t>s4</a:t>
-                      </a:r>
-                    </a:p>
-                  </a:txBody>
-                  <a:tcPr anchor="ctr">
-                    <a:solidFill>
-                      <a:srgbClr val="F4F7FB"/>
-                    </a:solidFill>
-                  </a:tcPr>
-                </a:tc>
-                <a:tc>
-                  <a:txBody>
-                    <a:bodyPr wrap="square"/>
-                    <a:lstStyle/>
-                    <a:p>
-                      <a:pPr algn="l"/>
-                      <a:r>
-                        <a:rPr sz="1300" b="0">
-                          <a:solidFill>
-                            <a:srgbClr val="1F2A37"/>
-                          </a:solidFill>
-                          <a:ea typeface="TH Sarabun New"/>
-                          <a:cs typeface="TH Sarabun New"/>
-                          <a:latin typeface="TH Sarabun New"/>
-                        </a:rPr>
-                        <a:t>ขอบเขตงาน + s4.1–s4.14</a:t>
-                      </a:r>
-                    </a:p>
-                  </a:txBody>
-                  <a:tcPr anchor="ctr">
-                    <a:solidFill>
-                      <a:srgbClr val="F4F7FB"/>
-                    </a:solidFill>
-                  </a:tcPr>
-                </a:tc>
-                <a:tc>
-                  <a:txBody>
-                    <a:bodyPr wrap="square"/>
-                    <a:lstStyle/>
-                    <a:p>
-                      <a:pPr algn="l"/>
-                      <a:r>
-                        <a:rPr sz="1300" b="0">
-                          <a:solidFill>
-                            <a:srgbClr val="1F2A37"/>
-                          </a:solidFill>
-                          <a:ea typeface="TH Sarabun New"/>
-                          <a:cs typeface="TH Sarabun New"/>
-                          <a:latin typeface="TH Sarabun New"/>
-                        </a:rPr>
-                        <a:t>ไม่ (บังคับย่อย s4.1, s4.8)</a:t>
-                      </a:r>
-                    </a:p>
-                  </a:txBody>
-                  <a:tcPr anchor="ctr">
-                    <a:solidFill>
-                      <a:srgbClr val="F4F7FB"/>
-                    </a:solidFill>
-                  </a:tcPr>
-                </a:tc>
-              </a:tr>
-              <a:tr h="594360">
-                <a:tc>
-                  <a:txBody>
-                    <a:bodyPr wrap="square"/>
-                    <a:lstStyle/>
-                    <a:p>
-                      <a:pPr algn="l"/>
-                      <a:r>
-                        <a:rPr sz="1300" b="0">
-                          <a:solidFill>
-                            <a:srgbClr val="1F2A37"/>
-                          </a:solidFill>
-                          <a:ea typeface="TH Sarabun New"/>
-                          <a:cs typeface="TH Sarabun New"/>
-                          <a:latin typeface="TH Sarabun New"/>
-                        </a:rPr>
-                        <a:t>s5 / s7</a:t>
-                      </a:r>
-                    </a:p>
-                  </a:txBody>
-                  <a:tcPr anchor="ctr">
-                    <a:solidFill>
-                      <a:srgbClr val="FFFFFF"/>
-                    </a:solidFill>
-                  </a:tcPr>
-                </a:tc>
-                <a:tc>
-                  <a:txBody>
-                    <a:bodyPr wrap="square"/>
-                    <a:lstStyle/>
-                    <a:p>
-                      <a:pPr algn="l"/>
-                      <a:r>
-                        <a:rPr sz="1300" b="0">
-                          <a:solidFill>
-                            <a:srgbClr val="1F2A37"/>
-                          </a:solidFill>
-                          <a:ea typeface="TH Sarabun New"/>
-                          <a:cs typeface="TH Sarabun New"/>
-                          <a:latin typeface="TH Sarabun New"/>
-                        </a:rPr>
-                        <a:t>ระยะเวลา / สถานที่</a:t>
-                      </a:r>
-                    </a:p>
-                  </a:txBody>
-                  <a:tcPr anchor="ctr">
-                    <a:solidFill>
-                      <a:srgbClr val="FFFFFF"/>
-                    </a:solidFill>
-                  </a:tcPr>
-                </a:tc>
-                <a:tc>
-                  <a:txBody>
-                    <a:bodyPr wrap="square"/>
-                    <a:lstStyle/>
-                    <a:p>
-                      <a:pPr algn="l"/>
-                      <a:r>
-                        <a:rPr sz="1300" b="0">
-                          <a:solidFill>
-                            <a:srgbClr val="1F2A37"/>
-                          </a:solidFill>
-                          <a:ea typeface="TH Sarabun New"/>
-                          <a:cs typeface="TH Sarabun New"/>
-                          <a:latin typeface="TH Sarabun New"/>
-                        </a:rPr>
-                        <a:t>ไม่</a:t>
-                      </a:r>
-                    </a:p>
-                  </a:txBody>
-                  <a:tcPr anchor="ctr">
-                    <a:solidFill>
-                      <a:srgbClr val="FFFFFF"/>
-                    </a:solidFill>
-                  </a:tcPr>
-                </a:tc>
-              </a:tr>
-              <a:tr h="594360">
-                <a:tc>
-                  <a:txBody>
-                    <a:bodyPr wrap="square"/>
-                    <a:lstStyle/>
-                    <a:p>
-                      <a:pPr algn="l"/>
-                      <a:r>
-                        <a:rPr sz="1300" b="0">
-                          <a:solidFill>
-                            <a:srgbClr val="1F2A37"/>
-                          </a:solidFill>
-                          <a:ea typeface="TH Sarabun New"/>
-                          <a:cs typeface="TH Sarabun New"/>
-                          <a:latin typeface="TH Sarabun New"/>
-                        </a:rPr>
-                        <a:t>s6 / s8</a:t>
-                      </a:r>
-                    </a:p>
-                  </a:txBody>
-                  <a:tcPr anchor="ctr">
-                    <a:solidFill>
-                      <a:srgbClr val="F4F7FB"/>
-                    </a:solidFill>
-                  </a:tcPr>
-                </a:tc>
-                <a:tc>
-                  <a:txBody>
-                    <a:bodyPr wrap="square"/>
-                    <a:lstStyle/>
-                    <a:p>
-                      <a:pPr algn="l"/>
-                      <a:r>
-                        <a:rPr sz="1300" b="0">
-                          <a:solidFill>
-                            <a:srgbClr val="1F2A37"/>
-                          </a:solidFill>
-                          <a:ea typeface="TH Sarabun New"/>
-                          <a:cs typeface="TH Sarabun New"/>
-                          <a:latin typeface="TH Sarabun New"/>
-                        </a:rPr>
-                        <a:t>งบประมาณ / งวดจ่าย</a:t>
-                      </a:r>
-                    </a:p>
-                  </a:txBody>
-                  <a:tcPr anchor="ctr">
-                    <a:solidFill>
-                      <a:srgbClr val="F4F7FB"/>
-                    </a:solidFill>
-                  </a:tcPr>
-                </a:tc>
-                <a:tc>
-                  <a:txBody>
-                    <a:bodyPr wrap="square"/>
-                    <a:lstStyle/>
-                    <a:p>
-                      <a:pPr algn="l"/>
-                      <a:r>
-                        <a:rPr sz="1300" b="0">
-                          <a:solidFill>
-                            <a:srgbClr val="1F2A37"/>
-                          </a:solidFill>
-                          <a:ea typeface="TH Sarabun New"/>
-                          <a:cs typeface="TH Sarabun New"/>
-                          <a:latin typeface="TH Sarabun New"/>
-                        </a:rPr>
-                        <a:t>ใช่</a:t>
-                      </a:r>
-                    </a:p>
-                  </a:txBody>
-                  <a:tcPr anchor="ctr">
-                    <a:solidFill>
-                      <a:srgbClr val="F4F7FB"/>
-                    </a:solidFill>
-                  </a:tcPr>
-                </a:tc>
-              </a:tr>
-              <a:tr h="594360">
-                <a:tc>
-                  <a:txBody>
-                    <a:bodyPr wrap="square"/>
-                    <a:lstStyle/>
-                    <a:p>
-                      <a:pPr algn="l"/>
-                      <a:r>
-                        <a:rPr sz="1300" b="0">
-                          <a:solidFill>
-                            <a:srgbClr val="1F2A37"/>
-                          </a:solidFill>
-                          <a:ea typeface="TH Sarabun New"/>
-                          <a:cs typeface="TH Sarabun New"/>
-                          <a:latin typeface="TH Sarabun New"/>
-                        </a:rPr>
-                        <a:t>s9 / s11 / s12</a:t>
-                      </a:r>
-                    </a:p>
-                  </a:txBody>
-                  <a:tcPr anchor="ctr">
-                    <a:solidFill>
-                      <a:srgbClr val="FFFFFF"/>
-                    </a:solidFill>
-                  </a:tcPr>
-                </a:tc>
-                <a:tc>
-                  <a:txBody>
-                    <a:bodyPr wrap="square"/>
-                    <a:lstStyle/>
-                    <a:p>
-                      <a:pPr algn="l"/>
-                      <a:r>
-                        <a:rPr sz="1300" b="0">
-                          <a:solidFill>
-                            <a:srgbClr val="1F2A37"/>
-                          </a:solidFill>
-                          <a:ea typeface="TH Sarabun New"/>
-                          <a:cs typeface="TH Sarabun New"/>
-                          <a:latin typeface="TH Sarabun New"/>
-                        </a:rPr>
-                        <a:t>รับประกัน / เกณฑ์ / เอกสารยื่น</a:t>
-                      </a:r>
-                    </a:p>
-                  </a:txBody>
-                  <a:tcPr anchor="ctr">
-                    <a:solidFill>
-                      <a:srgbClr val="FFFFFF"/>
-                    </a:solidFill>
-                  </a:tcPr>
-                </a:tc>
-                <a:tc>
-                  <a:txBody>
-                    <a:bodyPr wrap="square"/>
-                    <a:lstStyle/>
-                    <a:p>
-                      <a:pPr algn="l"/>
-                      <a:r>
-                        <a:rPr sz="1300" b="0">
-                          <a:solidFill>
-                            <a:srgbClr val="1F2A37"/>
-                          </a:solidFill>
-                          <a:ea typeface="TH Sarabun New"/>
-                          <a:cs typeface="TH Sarabun New"/>
-                          <a:latin typeface="TH Sarabun New"/>
-                        </a:rPr>
-                        <a:t>ไม่</a:t>
-                      </a:r>
-                    </a:p>
-                  </a:txBody>
-                  <a:tcPr anchor="ctr">
-                    <a:solidFill>
-                      <a:srgbClr val="FFFFFF"/>
-                    </a:solidFill>
-                  </a:tcPr>
-                </a:tc>
-              </a:tr>
-              <a:tr h="594360">
-                <a:tc>
-                  <a:txBody>
-                    <a:bodyPr wrap="square"/>
-                    <a:lstStyle/>
-                    <a:p>
-                      <a:pPr algn="l"/>
-                      <a:r>
-                        <a:rPr sz="1300" b="0">
-                          <a:solidFill>
-                            <a:srgbClr val="1F2A37"/>
-                          </a:solidFill>
-                          <a:ea typeface="TH Sarabun New"/>
-                          <a:cs typeface="TH Sarabun New"/>
-                          <a:latin typeface="TH Sarabun New"/>
-                        </a:rPr>
-                        <a:t>s10 / s13</a:t>
-                      </a:r>
-                    </a:p>
-                  </a:txBody>
-                  <a:tcPr anchor="ctr">
-                    <a:solidFill>
-                      <a:srgbClr val="F4F7FB"/>
-                    </a:solidFill>
-                  </a:tcPr>
-                </a:tc>
-                <a:tc>
-                  <a:txBody>
-                    <a:bodyPr wrap="square"/>
-                    <a:lstStyle/>
-                    <a:p>
-                      <a:pPr algn="l"/>
-                      <a:r>
-                        <a:rPr sz="1300" b="0">
-                          <a:solidFill>
-                            <a:srgbClr val="1F2A37"/>
-                          </a:solidFill>
-                          <a:ea typeface="TH Sarabun New"/>
-                          <a:cs typeface="TH Sarabun New"/>
-                          <a:latin typeface="TH Sarabun New"/>
-                        </a:rPr>
-                        <a:t>ค่าปรับ / เงื่อนไขอื่น</a:t>
-                      </a:r>
-                    </a:p>
-                  </a:txBody>
-                  <a:tcPr anchor="ctr">
-                    <a:solidFill>
-                      <a:srgbClr val="F4F7FB"/>
-                    </a:solidFill>
-                  </a:tcPr>
-                </a:tc>
-                <a:tc>
-                  <a:txBody>
-                    <a:bodyPr wrap="square"/>
-                    <a:lstStyle/>
-                    <a:p>
-                      <a:pPr algn="l"/>
-                      <a:r>
-                        <a:rPr sz="1300" b="0">
-                          <a:solidFill>
-                            <a:srgbClr val="1F2A37"/>
-                          </a:solidFill>
-                          <a:ea typeface="TH Sarabun New"/>
-                          <a:cs typeface="TH Sarabun New"/>
-                          <a:latin typeface="TH Sarabun New"/>
-                        </a:rPr>
-                        <a:t>ใช่</a:t>
                       </a:r>
                     </a:p>
                   </a:txBody>

</xml_diff>

<commit_message>
Add sequential Phase 2/3 drafting chat and resolve draft-chat Sonar findings.
Keep fact-slot intake conversational, auto-draft TOR sections with intake context on edits, and give live embedding ingest enough time under real LM Studio load.
</commit_message>
<xml_diff>
--- a/Discussions/19-APPLICATION_OPERATING_REPORT.pptx
+++ b/Discussions/19-APPLICATION_OPERATING_REPORT.pptx
@@ -3340,7 +3340,7 @@
                 <a:cs typeface="TH Sarabun New"/>
                 <a:latin typeface="TH Sarabun New"/>
               </a:rPr>
-              <a:t>เวอร์ชัน 0.2.3   ·   20 สิงหาคม 2026   ·   Next.js 14 + FastAPI + LangGraph</a:t>
+              <a:t>เวอร์ชัน 0.2.3   ·   21 สิงหาคม 2026   ·   Next.js 14 + FastAPI + LangGraph</a:t>
             </a:r>
           </a:p>
         </p:txBody>
@@ -3498,7 +3498,7 @@
                 <a:cs typeface="TH Sarabun New"/>
                 <a:latin typeface="TH Sarabun New"/>
               </a:rPr>
-              <a:t>TOR Generator  v0.2.3   ·   รายงานการทำงาน   ·   20 ส.ค. 2026</a:t>
+              <a:t>TOR Generator  v0.2.3   ·   รายงานการทำงาน   ·   21 ส.ค. 2026</a:t>
             </a:r>
           </a:p>
         </p:txBody>
@@ -4336,7 +4336,7 @@
                 <a:cs typeface="TH Sarabun New"/>
                 <a:latin typeface="TH Sarabun New"/>
               </a:rPr>
-              <a:t>TOR Generator  v0.2.3   ·   รายงานการทำงาน   ·   20 ส.ค. 2026</a:t>
+              <a:t>TOR Generator  v0.2.3   ·   รายงานการทำงาน   ·   21 ส.ค. 2026</a:t>
             </a:r>
           </a:p>
         </p:txBody>
@@ -4555,7 +4555,7 @@
                 <a:cs typeface="TH Sarabun New"/>
                 <a:latin typeface="TH Sarabun New"/>
               </a:rPr>
-              <a:t>TOR Generator  v0.2.3   ·   รายงานการทำงาน   ·   20 ส.ค. 2026</a:t>
+              <a:t>TOR Generator  v0.2.3   ·   รายงานการทำงาน   ·   21 ส.ค. 2026</a:t>
             </a:r>
           </a:p>
         </p:txBody>
@@ -5239,7 +5239,7 @@
                 <a:cs typeface="TH Sarabun New"/>
                 <a:latin typeface="TH Sarabun New"/>
               </a:rPr>
-              <a:t>TOR Generator  v0.2.3   ·   รายงานการทำงาน   ·   20 ส.ค. 2026</a:t>
+              <a:t>TOR Generator  v0.2.3   ·   รายงานการทำงาน   ·   21 ส.ค. 2026</a:t>
             </a:r>
           </a:p>
         </p:txBody>
@@ -5298,7 +5298,7 @@
         <p:spPr>
           <a:xfrm>
             <a:off x="320040" y="868680"/>
-            <a:ext cx="5669280" cy="9496541"/>
+            <a:ext cx="5669280" cy="3543300"/>
           </a:xfrm>
           <a:prstGeom prst="rect">
             <a:avLst/>
@@ -5322,7 +5322,7 @@
         <p:spPr>
           <a:xfrm>
             <a:off x="6217920" y="868680"/>
-            <a:ext cx="5577840" cy="6885207"/>
+            <a:ext cx="5577840" cy="5804868"/>
           </a:xfrm>
           <a:prstGeom prst="rect">
             <a:avLst/>
@@ -5556,7 +5556,7 @@
                 <a:cs typeface="TH Sarabun New"/>
                 <a:latin typeface="TH Sarabun New"/>
               </a:rPr>
-              <a:t>TOR Generator  v0.2.3   ·   รายงานการทำงาน   ·   20 ส.ค. 2026</a:t>
+              <a:t>TOR Generator  v0.2.3   ·   รายงานการทำงาน   ·   21 ส.ค. 2026</a:t>
             </a:r>
           </a:p>
         </p:txBody>
@@ -5934,7 +5934,7 @@
                 <a:cs typeface="TH Sarabun New"/>
                 <a:latin typeface="TH Sarabun New"/>
               </a:rPr>
-              <a:t>TOR Generator  v0.2.3   ·   รายงานการทำงาน   ·   20 ส.ค. 2026</a:t>
+              <a:t>TOR Generator  v0.2.3   ·   รายงานการทำงาน   ·   21 ส.ค. 2026</a:t>
             </a:r>
           </a:p>
         </p:txBody>
@@ -6260,7 +6260,7 @@
                 <a:cs typeface="TH Sarabun New"/>
                 <a:latin typeface="TH Sarabun New"/>
               </a:rPr>
-              <a:t>TOR Generator  v0.2.3   ·   รายงานการทำงาน   ·   20 ส.ค. 2026</a:t>
+              <a:t>TOR Generator  v0.2.3   ·   รายงานการทำงาน   ·   21 ส.ค. 2026</a:t>
             </a:r>
           </a:p>
         </p:txBody>
@@ -6845,7 +6845,7 @@
                 <a:cs typeface="TH Sarabun New"/>
                 <a:latin typeface="TH Sarabun New"/>
               </a:rPr>
-              <a:t>TOR Generator  v0.2.3   ·   รายงานการทำงาน   ·   20 ส.ค. 2026</a:t>
+              <a:t>TOR Generator  v0.2.3   ·   รายงานการทำงาน   ·   21 ส.ค. 2026</a:t>
             </a:r>
           </a:p>
         </p:txBody>
@@ -7566,7 +7566,7 @@
                 <a:cs typeface="TH Sarabun New"/>
                 <a:latin typeface="TH Sarabun New"/>
               </a:rPr>
-              <a:t>TOR Generator  v0.2.3   ·   รายงานการทำงาน   ·   20 ส.ค. 2026</a:t>
+              <a:t>TOR Generator  v0.2.3   ·   รายงานการทำงาน   ·   21 ส.ค. 2026</a:t>
             </a:r>
           </a:p>
         </p:txBody>
@@ -8099,7 +8099,7 @@
                 <a:cs typeface="TH Sarabun New"/>
                 <a:latin typeface="TH Sarabun New"/>
               </a:rPr>
-              <a:t>TOR Generator  v0.2.3   ·   รายงานการทำงาน   ·   20 ส.ค. 2026</a:t>
+              <a:t>TOR Generator  v0.2.3   ·   รายงานการทำงาน   ·   21 ส.ค. 2026</a:t>
             </a:r>
           </a:p>
         </p:txBody>
@@ -8736,7 +8736,7 @@
                 <a:cs typeface="TH Sarabun New"/>
                 <a:latin typeface="TH Sarabun New"/>
               </a:rPr>
-              <a:t>TOR Generator  v0.2.3   ·   รายงานการทำงาน   ·   20 ส.ค. 2026</a:t>
+              <a:t>TOR Generator  v0.2.3   ·   รายงานการทำงาน   ·   21 ส.ค. 2026</a:t>
             </a:r>
           </a:p>
         </p:txBody>
@@ -9153,7 +9153,7 @@
                           <a:cs typeface="TH Sarabun New"/>
                           <a:latin typeface="TH Sarabun New"/>
                         </a:rPr>
-                        <a:t>Unit tests จริง 20 ส.ค. 2026 (Vitest 128 / pytest 1448 + live 10 / E2E headed 15)</a:t>
+                        <a:t>Unit tests จริง 21 ส.ค. 2026 (Vitest 167 / pytest 1500 + live 14 / E2E headed 20)</a:t>
                       </a:r>
                     </a:p>
                   </a:txBody>
@@ -9321,7 +9321,7 @@
                 <a:cs typeface="TH Sarabun New"/>
                 <a:latin typeface="TH Sarabun New"/>
               </a:rPr>
-              <a:t>TOR Generator  v0.2.3   ·   รายงานการทำงาน   ·   20 ส.ค. 2026</a:t>
+              <a:t>TOR Generator  v0.2.3   ·   รายงานการทำงาน   ·   21 ส.ค. 2026</a:t>
             </a:r>
           </a:p>
         </p:txBody>
@@ -9358,7 +9358,7 @@
                 <a:cs typeface="TH Sarabun New"/>
                 <a:latin typeface="TH Sarabun New"/>
               </a:rPr>
-              <a:t>Unit tests ที่รันจริง — 20 ส.ค. 2026</a:t>
+              <a:t>Unit tests ที่รันจริง — 21 ส.ค. 2026</a:t>
             </a:r>
           </a:p>
         </p:txBody>
@@ -9564,7 +9564,7 @@
                 <a:cs typeface="TH Sarabun New"/>
                 <a:latin typeface="TH Sarabun New"/>
               </a:rPr>
-              <a:t>TOR Generator  v0.2.3   ·   รายงานการทำงาน   ·   20 ส.ค. 2026</a:t>
+              <a:t>TOR Generator  v0.2.3   ·   รายงานการทำงาน   ·   21 ส.ค. 2026</a:t>
             </a:r>
           </a:p>
         </p:txBody>
@@ -9783,7 +9783,7 @@
                 <a:cs typeface="TH Sarabun New"/>
                 <a:latin typeface="TH Sarabun New"/>
               </a:rPr>
-              <a:t>TOR Generator  v0.2.3   ·   รายงานการทำงาน   ·   20 ส.ค. 2026</a:t>
+              <a:t>TOR Generator  v0.2.3   ·   รายงานการทำงาน   ·   21 ส.ค. 2026</a:t>
             </a:r>
           </a:p>
         </p:txBody>
@@ -9969,7 +9969,7 @@
                 <a:cs typeface="TH Sarabun New"/>
                 <a:latin typeface="TH Sarabun New"/>
               </a:rPr>
-              <a:t>•  live_llm 10 เคสผ่านเมื่อเปิด LM Studio ที่ :1234 — รวม backend 1458 เคส</a:t>
+              <a:t>•  live_llm 14 เคสผ่านเมื่อเปิด LM Studio ที่ :1234 — รวม backend 1514 เคส</a:t>
             </a:r>
           </a:p>
         </p:txBody>
@@ -10127,7 +10127,7 @@
                 <a:cs typeface="TH Sarabun New"/>
                 <a:latin typeface="TH Sarabun New"/>
               </a:rPr>
-              <a:t>TOR Generator  v0.2.3   ·   รายงานการทำงาน   ·   20 ส.ค. 2026</a:t>
+              <a:t>TOR Generator  v0.2.3   ·   รายงานการทำงาน   ·   21 ส.ค. 2026</a:t>
             </a:r>
           </a:p>
         </p:txBody>
@@ -10435,7 +10435,7 @@
                 <a:cs typeface="TH Sarabun New"/>
                 <a:latin typeface="TH Sarabun New"/>
               </a:rPr>
-              <a:t>TOR Generator  v0.2.3   ·   รายงานการทำงาน   ·   20 ส.ค. 2026</a:t>
+              <a:t>TOR Generator  v0.2.3   ·   รายงานการทำงาน   ·   21 ส.ค. 2026</a:t>
             </a:r>
           </a:p>
         </p:txBody>
@@ -10567,7 +10567,7 @@
                 <a:cs typeface="TH Sarabun New"/>
                 <a:latin typeface="TH Sarabun New"/>
               </a:rPr>
-              <a:t>•  Unit tests ล็อกพฤติกรรมนี้ไว้แล้ว: Vitest 128, pytest 1448 + live_llm 10, Playwright headed 15</a:t>
+              <a:t>•  Unit tests ล็อกพฤติกรรมนี้ไว้แล้ว: Vitest 167, pytest 1500 + live_llm 14, Playwright headed 20</a:t>
             </a:r>
           </a:p>
           <a:p>
@@ -10743,7 +10743,7 @@
                 <a:cs typeface="TH Sarabun New"/>
                 <a:latin typeface="TH Sarabun New"/>
               </a:rPr>
-              <a:t>TOR Generator  v0.2.3   ·   รายงานการทำงาน   ·   20 ส.ค. 2026</a:t>
+              <a:t>TOR Generator  v0.2.3   ·   รายงานการทำงาน   ·   21 ส.ค. 2026</a:t>
             </a:r>
           </a:p>
         </p:txBody>
@@ -11051,7 +11051,7 @@
                 <a:cs typeface="TH Sarabun New"/>
                 <a:latin typeface="TH Sarabun New"/>
               </a:rPr>
-              <a:t>TOR Generator  v0.2.3   ·   รายงานการทำงาน   ·   20 ส.ค. 2026</a:t>
+              <a:t>TOR Generator  v0.2.3   ·   รายงานการทำงาน   ·   21 ส.ค. 2026</a:t>
             </a:r>
           </a:p>
         </p:txBody>
@@ -11270,7 +11270,7 @@
                 <a:cs typeface="TH Sarabun New"/>
                 <a:latin typeface="TH Sarabun New"/>
               </a:rPr>
-              <a:t>TOR Generator  v0.2.3   ·   รายงานการทำงาน   ·   20 ส.ค. 2026</a:t>
+              <a:t>TOR Generator  v0.2.3   ·   รายงานการทำงาน   ·   21 ส.ค. 2026</a:t>
             </a:r>
           </a:p>
         </p:txBody>
@@ -11839,7 +11839,7 @@
                 <a:cs typeface="TH Sarabun New"/>
                 <a:latin typeface="TH Sarabun New"/>
               </a:rPr>
-              <a:t>TOR Generator  v0.2.3   ·   รายงานการทำงาน   ·   20 ส.ค. 2026</a:t>
+              <a:t>TOR Generator  v0.2.3   ·   รายงานการทำงาน   ·   21 ส.ค. 2026</a:t>
             </a:r>
           </a:p>
         </p:txBody>
@@ -11922,7 +11922,7 @@
         <p:spPr>
           <a:xfrm>
             <a:off x="6126480" y="914400"/>
-            <a:ext cx="5577840" cy="3486150"/>
+            <a:ext cx="5577840" cy="6810836"/>
           </a:xfrm>
           <a:prstGeom prst="rect">
             <a:avLst/>
@@ -12156,7 +12156,7 @@
                 <a:cs typeface="TH Sarabun New"/>
                 <a:latin typeface="TH Sarabun New"/>
               </a:rPr>
-              <a:t>TOR Generator  v0.2.3   ·   รายงานการทำงาน   ·   20 ส.ค. 2026</a:t>
+              <a:t>TOR Generator  v0.2.3   ·   รายงานการทำงาน   ·   21 ส.ค. 2026</a:t>
             </a:r>
           </a:p>
         </p:txBody>
@@ -12734,7 +12734,7 @@
                 <a:cs typeface="TH Sarabun New"/>
                 <a:latin typeface="TH Sarabun New"/>
               </a:rPr>
-              <a:t>TOR Generator  v0.2.3   ·   รายงานการทำงาน   ·   20 ส.ค. 2026</a:t>
+              <a:t>TOR Generator  v0.2.3   ·   รายงานการทำงาน   ·   21 ส.ค. 2026</a:t>
             </a:r>
           </a:p>
         </p:txBody>
@@ -13267,7 +13267,7 @@
                 <a:cs typeface="TH Sarabun New"/>
                 <a:latin typeface="TH Sarabun New"/>
               </a:rPr>
-              <a:t>TOR Generator  v0.2.3   ·   รายงานการทำงาน   ·   20 ส.ค. 2026</a:t>
+              <a:t>TOR Generator  v0.2.3   ·   รายงานการทำงาน   ·   21 ส.ค. 2026</a:t>
             </a:r>
           </a:p>
         </p:txBody>

</xml_diff>